<commit_message>
System Design vi: sd-14-032 and sd-14-033 decks list every glossary term on the last slide
Co-Authored-By: Claude Sonnet 5.5 <noreply@anthropic.com>
Claude-Session: https://claude.ai/code/session_01WnjciXNJBLEd8jy3HrG49S
</commit_message>
<xml_diff>
--- a/system-design-101/vi/lessons/sd-14-033/slides/sd-14-033.pptx
+++ b/system-design-101/vi/lessons/sd-14-033/slides/sd-14-033.pptx
@@ -3997,8 +3997,8 @@
         </p:nvSpPr>
         <p:spPr>
           <a:xfrm>
-            <a:off x="914400" y="1333500"/>
-            <a:ext cx="15430500" cy="1238250"/>
+            <a:off x="914400" y="1314450"/>
+            <a:ext cx="15430500" cy="800100"/>
           </a:xfrm>
           <a:prstGeom prst="rect">
             <a:avLst/>
@@ -4007,17 +4007,17 @@
           <a:ln/>
         </p:spPr>
         <p:txBody>
-          <a:bodyPr wrap="square" lIns="0" tIns="66675" rIns="0" bIns="-66675" rtlCol="0" anchor="t"/>
+          <a:bodyPr wrap="square" lIns="0" tIns="42672" rIns="0" bIns="-42672" rtlCol="0" anchor="t"/>
           <a:lstStyle/>
           <a:p>
             <a:pPr algn="l" indent="0" marL="0">
               <a:lnSpc>
-                <a:spcPts val="7800"/>
+                <a:spcPts val="4992"/>
               </a:lnSpc>
               <a:buNone/>
             </a:pPr>
             <a:r>
-              <a:rPr lang="en-US" sz="7500" dirty="0" spc="-64" kern="0">
+              <a:rPr lang="en-US" sz="4800" dirty="0" spc="-35" kern="0">
                 <a:solidFill>
                   <a:srgbClr val="F3EEE3"/>
                 </a:solidFill>
@@ -4028,7 +4028,7 @@
               <a:t>Từ</a:t>
             </a:r>
             <a:r>
-              <a:rPr lang="en-US" sz="7500" dirty="0" spc="-8" kern="0">
+              <a:rPr lang="en-US" sz="4800" dirty="0" spc="-8" kern="0">
                 <a:solidFill>
                   <a:srgbClr val="F3EEE3"/>
                 </a:solidFill>
@@ -4039,7 +4039,7 @@
               <a:t> khóa</a:t>
             </a:r>
             <a:r>
-              <a:rPr lang="en-US" sz="7500" dirty="0" spc="0" kern="0">
+              <a:rPr lang="en-US" sz="4800" dirty="0" spc="-2" kern="0">
                 <a:solidFill>
                   <a:srgbClr val="F3EEE3"/>
                 </a:solidFill>
@@ -4047,20 +4047,9 @@
                 <a:ea typeface="Bricolage Grotesque ExtraBold" pitchFamily="34" charset="-122"/>
                 <a:cs typeface="Bricolage Grotesque ExtraBold" pitchFamily="34" charset="-120"/>
               </a:rPr>
-              <a:t> cần</a:t>
-            </a:r>
-            <a:r>
-              <a:rPr lang="en-US" sz="7500" dirty="0" spc="2" kern="0">
-                <a:solidFill>
-                  <a:srgbClr val="F3EEE3"/>
-                </a:solidFill>
-                <a:latin typeface="Bricolage Grotesque ExtraBold" pitchFamily="34" charset="0"/>
-                <a:ea typeface="Bricolage Grotesque ExtraBold" pitchFamily="34" charset="-122"/>
-                <a:cs typeface="Bricolage Grotesque ExtraBold" pitchFamily="34" charset="-120"/>
-              </a:rPr>
-              <a:t> nhớ</a:t>
-            </a:r>
-            <a:endParaRPr lang="en-US" sz="7500" dirty="0"/>
+              <a:t> cần nhớ</a:t>
+            </a:r>
+            <a:endParaRPr lang="en-US" sz="4800" dirty="0"/>
           </a:p>
         </p:txBody>
       </p:sp>
@@ -4072,12 +4061,12 @@
         </p:nvSpPr>
         <p:spPr>
           <a:xfrm>
-            <a:off x="914400" y="2571750"/>
-            <a:ext cx="5334000" cy="2209800"/>
+            <a:off x="914400" y="2438400"/>
+            <a:ext cx="4000500" cy="2286000"/>
           </a:xfrm>
           <a:prstGeom prst="roundRect">
             <a:avLst>
-              <a:gd name="adj" fmla="val 11207"/>
+              <a:gd name="adj" fmla="val 9167"/>
             </a:avLst>
           </a:prstGeom>
           <a:solidFill>
@@ -4088,14 +4077,14 @@
       </p:sp>
       <p:sp>
         <p:nvSpPr>
-          <p:cNvPr id="5" name="Connector line-1792369924344-755282891"/>
-          <p:cNvSpPr/>
-          <p:nvPr/>
-        </p:nvSpPr>
-        <p:spPr>
-          <a:xfrm>
-            <a:off x="1162050" y="2819400"/>
-            <a:ext cx="4838700" cy="0"/>
+          <p:cNvPr id="5" name="Connector line-1792390670781-73893505"/>
+          <p:cNvSpPr/>
+          <p:nvPr/>
+        </p:nvSpPr>
+        <p:spPr>
+          <a:xfrm>
+            <a:off x="1162050" y="2686050"/>
+            <a:ext cx="3505200" cy="0"/>
           </a:xfrm>
           <a:prstGeom prst="line">
             <a:avLst/>
@@ -4119,7 +4108,7 @@
         </p:nvSpPr>
         <p:spPr>
           <a:xfrm>
-            <a:off x="1085850" y="2743200"/>
+            <a:off x="1085850" y="2609850"/>
             <a:ext cx="152400" cy="152400"/>
           </a:xfrm>
           <a:prstGeom prst="ellipse">
@@ -4144,8 +4133,8 @@
         </p:nvSpPr>
         <p:spPr>
           <a:xfrm>
-            <a:off x="1162050" y="3009900"/>
-            <a:ext cx="4762500" cy="647700"/>
+            <a:off x="1181100" y="2914650"/>
+            <a:ext cx="3467100" cy="1714500"/>
           </a:xfrm>
           <a:prstGeom prst="rect">
             <a:avLst/>
@@ -4154,117 +4143,85 @@
           <a:ln/>
         </p:spPr>
         <p:txBody>
-          <a:bodyPr wrap="square" lIns="0" tIns="0" rIns="0" bIns="0" rtlCol="0" anchor="t"/>
-          <a:lstStyle/>
-          <a:p>
-            <a:pPr algn="l" indent="0" marL="0">
-              <a:buNone/>
-            </a:pPr>
-            <a:r>
-              <a:rPr lang="en-US" sz="3900" dirty="0" spc="13" kern="0">
-                <a:solidFill>
-                  <a:srgbClr val="FFB454"/>
-                </a:solidFill>
-                <a:latin typeface="Bricolage Grotesque ExtraBold" pitchFamily="34" charset="0"/>
-                <a:ea typeface="Bricolage Grotesque ExtraBold" pitchFamily="34" charset="-122"/>
-                <a:cs typeface="Bricolage Grotesque ExtraBold" pitchFamily="34" charset="-120"/>
-              </a:rPr>
-              <a:t>JWT</a:t>
-            </a:r>
-            <a:endParaRPr lang="en-US" sz="3900" dirty="0"/>
-          </a:p>
-        </p:txBody>
-      </p:sp>
-      <p:sp>
-        <p:nvSpPr>
-          <p:cNvPr id="8" name="Text 6"/>
-          <p:cNvSpPr/>
-          <p:nvPr/>
-        </p:nvSpPr>
-        <p:spPr>
-          <a:xfrm>
-            <a:off x="1162050" y="3657600"/>
-            <a:ext cx="4857750" cy="285750"/>
-          </a:xfrm>
-          <a:prstGeom prst="rect">
-            <a:avLst/>
-          </a:prstGeom>
-          <a:noFill/>
-          <a:ln/>
-        </p:spPr>
-        <p:txBody>
-          <a:bodyPr wrap="square" lIns="0" tIns="0" rIns="0" bIns="0" rtlCol="0" anchor="t"/>
-          <a:lstStyle/>
-          <a:p>
-            <a:pPr algn="l" indent="0" marL="0">
-              <a:buNone/>
-            </a:pPr>
-            <a:r>
-              <a:rPr lang="en-US" sz="1650" dirty="0" spc="6" kern="0">
-                <a:solidFill>
-                  <a:srgbClr val="9A98A0"/>
-                </a:solidFill>
-                <a:latin typeface="Be Vietnam Pro" pitchFamily="34" charset="0"/>
-                <a:ea typeface="Be Vietnam Pro" pitchFamily="34" charset="-122"/>
-                <a:cs typeface="Be Vietnam Pro" pitchFamily="34" charset="-120"/>
-              </a:rPr>
-              <a:t>JSON</a:t>
-            </a:r>
-            <a:r>
-              <a:rPr lang="en-US" sz="1650" dirty="0" spc="-18" kern="0">
-                <a:solidFill>
-                  <a:srgbClr val="9A98A0"/>
-                </a:solidFill>
-                <a:latin typeface="Be Vietnam Pro" pitchFamily="34" charset="0"/>
-                <a:ea typeface="Be Vietnam Pro" pitchFamily="34" charset="-122"/>
-                <a:cs typeface="Be Vietnam Pro" pitchFamily="34" charset="-120"/>
-              </a:rPr>
-              <a:t> Web</a:t>
-            </a:r>
-            <a:r>
-              <a:rPr lang="en-US" sz="1650" dirty="0" spc="-38" kern="0">
-                <a:solidFill>
-                  <a:srgbClr val="9A98A0"/>
-                </a:solidFill>
-                <a:latin typeface="Be Vietnam Pro" pitchFamily="34" charset="0"/>
-                <a:ea typeface="Be Vietnam Pro" pitchFamily="34" charset="-122"/>
-                <a:cs typeface="Be Vietnam Pro" pitchFamily="34" charset="-120"/>
-              </a:rPr>
-              <a:t> Token</a:t>
-            </a:r>
-            <a:endParaRPr lang="en-US" sz="1650" dirty="0"/>
-          </a:p>
-        </p:txBody>
-      </p:sp>
-      <p:sp>
-        <p:nvSpPr>
-          <p:cNvPr id="9" name="Text 7"/>
-          <p:cNvSpPr/>
-          <p:nvPr/>
-        </p:nvSpPr>
-        <p:spPr>
-          <a:xfrm>
-            <a:off x="1162050" y="3962400"/>
-            <a:ext cx="4857750" cy="723900"/>
-          </a:xfrm>
-          <a:prstGeom prst="rect">
-            <a:avLst/>
-          </a:prstGeom>
-          <a:noFill/>
-          <a:ln/>
-        </p:spPr>
-        <p:txBody>
-          <a:bodyPr wrap="square" lIns="0" tIns="11335" rIns="0" bIns="-11335" rtlCol="0" anchor="t"/>
+          <a:bodyPr wrap="square" lIns="0" tIns="16192" rIns="0" bIns="-16192" rtlCol="0" anchor="t"/>
           <a:lstStyle/>
           <a:p>
             <a:pPr algn="l" indent="0" marL="0">
               <a:lnSpc>
-                <a:spcPts val="2730"/>
+                <a:spcPts val="2805"/>
+              </a:lnSpc>
+              <a:spcAft>
+                <a:spcPts val="600"/>
+              </a:spcAft>
+              <a:buNone/>
+            </a:pPr>
+            <a:r>
+              <a:rPr lang="en-US" sz="2550" dirty="0" spc="7" kern="0">
+                <a:solidFill>
+                  <a:srgbClr val="FFB454"/>
+                </a:solidFill>
+                <a:latin typeface="Bricolage Grotesque ExtraBold" pitchFamily="34" charset="0"/>
+                <a:ea typeface="Bricolage Grotesque ExtraBold" pitchFamily="34" charset="-122"/>
+                <a:cs typeface="Bricolage Grotesque ExtraBold" pitchFamily="34" charset="-120"/>
+              </a:rPr>
+              <a:t>JWT</a:t>
+            </a:r>
+            <a:endParaRPr lang="en-US" sz="2550" dirty="0"/>
+          </a:p>
+          <a:p>
+            <a:pPr algn="l" indent="0" marL="0">
+              <a:lnSpc>
+                <a:spcPts val="2145"/>
+              </a:lnSpc>
+              <a:spcAft>
+                <a:spcPts val="600"/>
+              </a:spcAft>
+              <a:buNone/>
+            </a:pPr>
+            <a:r>
+              <a:rPr lang="en-US" sz="1650" dirty="0" spc="6" kern="0">
+                <a:solidFill>
+                  <a:srgbClr val="9A98A0"/>
+                </a:solidFill>
+                <a:latin typeface="Be Vietnam Pro" pitchFamily="34" charset="0"/>
+                <a:ea typeface="Be Vietnam Pro" pitchFamily="34" charset="-122"/>
+                <a:cs typeface="Be Vietnam Pro" pitchFamily="34" charset="-120"/>
+              </a:rPr>
+              <a:t>JSON</a:t>
+            </a:r>
+            <a:r>
+              <a:rPr lang="en-US" sz="1650" dirty="0" spc="-18" kern="0">
+                <a:solidFill>
+                  <a:srgbClr val="9A98A0"/>
+                </a:solidFill>
+                <a:latin typeface="Be Vietnam Pro" pitchFamily="34" charset="0"/>
+                <a:ea typeface="Be Vietnam Pro" pitchFamily="34" charset="-122"/>
+                <a:cs typeface="Be Vietnam Pro" pitchFamily="34" charset="-120"/>
+              </a:rPr>
+              <a:t> Web</a:t>
+            </a:r>
+            <a:r>
+              <a:rPr lang="en-US" sz="1650" dirty="0" spc="-38" kern="0">
+                <a:solidFill>
+                  <a:srgbClr val="9A98A0"/>
+                </a:solidFill>
+                <a:latin typeface="Be Vietnam Pro" pitchFamily="34" charset="0"/>
+                <a:ea typeface="Be Vietnam Pro" pitchFamily="34" charset="-122"/>
+                <a:cs typeface="Be Vietnam Pro" pitchFamily="34" charset="-120"/>
+              </a:rPr>
+              <a:t> Token</a:t>
+            </a:r>
+            <a:endParaRPr lang="en-US" sz="2550" dirty="0"/>
+          </a:p>
+          <a:p>
+            <a:pPr algn="l" indent="0" marL="0">
+              <a:lnSpc>
+                <a:spcPts val="2145"/>
               </a:lnSpc>
               <a:buNone/>
             </a:pPr>
             <a:r>
-              <a:rPr lang="en-US" sz="2100" dirty="0" spc="-56" kern="0">
+              <a:rPr lang="en-US" sz="1650" dirty="0" spc="-46" kern="0">
                 <a:solidFill>
                   <a:srgbClr val="D8D3C4"/>
                 </a:solidFill>
@@ -4275,7 +4232,7 @@
               <a:t>Token</a:t>
             </a:r>
             <a:r>
-              <a:rPr lang="en-US" sz="2100" dirty="0" spc="-1" kern="0">
+              <a:rPr lang="en-US" sz="1650" dirty="0" spc="4" kern="0">
                 <a:solidFill>
                   <a:srgbClr val="D8D3C4"/>
                 </a:solidFill>
@@ -4283,10 +4240,10 @@
                 <a:ea typeface="Be Vietnam Pro" pitchFamily="34" charset="-122"/>
                 <a:cs typeface="Be Vietnam Pro" pitchFamily="34" charset="-120"/>
               </a:rPr>
-              <a:t> tự mang thông</a:t>
-            </a:r>
-            <a:r>
-              <a:rPr lang="en-US" sz="2100" dirty="0" spc="0" kern="0">
+              <a:t> tự</a:t>
+            </a:r>
+            <a:r>
+              <a:rPr lang="en-US" sz="1650" dirty="0" spc="-1" kern="0">
                 <a:solidFill>
                   <a:srgbClr val="D8D3C4"/>
                 </a:solidFill>
@@ -4294,10 +4251,32 @@
                 <a:ea typeface="Be Vietnam Pro" pitchFamily="34" charset="-122"/>
                 <a:cs typeface="Be Vietnam Pro" pitchFamily="34" charset="-120"/>
               </a:rPr>
+              <a:t> mang</a:t>
+            </a:r>
+            <a:r>
+              <a:rPr lang="en-US" sz="1650" dirty="0" spc="1" kern="0">
+                <a:solidFill>
+                  <a:srgbClr val="D8D3C4"/>
+                </a:solidFill>
+                <a:latin typeface="Be Vietnam Pro" pitchFamily="34" charset="0"/>
+                <a:ea typeface="Be Vietnam Pro" pitchFamily="34" charset="-122"/>
+                <a:cs typeface="Be Vietnam Pro" pitchFamily="34" charset="-120"/>
+              </a:rPr>
+              <a:t> thông</a:t>
+            </a:r>
+            <a:r>
+              <a:rPr lang="en-US" sz="1650" dirty="0" spc="0" kern="0">
+                <a:solidFill>
+                  <a:srgbClr val="D8D3C4"/>
+                </a:solidFill>
+                <a:latin typeface="Be Vietnam Pro" pitchFamily="34" charset="0"/>
+                <a:ea typeface="Be Vietnam Pro" pitchFamily="34" charset="-122"/>
+                <a:cs typeface="Be Vietnam Pro" pitchFamily="34" charset="-120"/>
+              </a:rPr>
               <a:t> tin</a:t>
             </a:r>
             <a:r>
-              <a:rPr lang="en-US" sz="2100" dirty="0" spc="5" kern="0">
+              <a:rPr lang="en-US" sz="1650" dirty="0" spc="-8" kern="0">
                 <a:solidFill>
                   <a:srgbClr val="D8D3C4"/>
                 </a:solidFill>
@@ -4305,10 +4284,10 @@
                 <a:ea typeface="Be Vietnam Pro" pitchFamily="34" charset="-122"/>
                 <a:cs typeface="Be Vietnam Pro" pitchFamily="34" charset="-120"/>
               </a:rPr>
-              <a:t> người</a:t>
-            </a:r>
-            <a:r>
-              <a:rPr lang="en-US" sz="2100" dirty="0" spc="-1" kern="0">
+              <a:t> và</a:t>
+            </a:r>
+            <a:r>
+              <a:rPr lang="en-US" sz="1650" dirty="0" spc="1" kern="0">
                 <a:solidFill>
                   <a:srgbClr val="D8D3C4"/>
                 </a:solidFill>
@@ -4316,59 +4295,26 @@
                 <a:ea typeface="Be Vietnam Pro" pitchFamily="34" charset="-122"/>
                 <a:cs typeface="Be Vietnam Pro" pitchFamily="34" charset="-120"/>
               </a:rPr>
-              <a:t> dùng</a:t>
-            </a:r>
-            <a:r>
-              <a:rPr lang="en-US" sz="2100" dirty="0" spc="-18" kern="0">
-                <a:solidFill>
-                  <a:srgbClr val="D8D3C4"/>
-                </a:solidFill>
-                <a:latin typeface="Be Vietnam Pro" pitchFamily="34" charset="0"/>
-                <a:ea typeface="Be Vietnam Pro" pitchFamily="34" charset="-122"/>
-                <a:cs typeface="Be Vietnam Pro" pitchFamily="34" charset="-120"/>
-              </a:rPr>
-              <a:t> và</a:t>
-            </a:r>
-            <a:r>
-              <a:rPr lang="en-US" sz="2100" dirty="0" spc="0" kern="0">
-                <a:solidFill>
-                  <a:srgbClr val="D8D3C4"/>
-                </a:solidFill>
-                <a:latin typeface="Be Vietnam Pro" pitchFamily="34" charset="0"/>
-                <a:ea typeface="Be Vietnam Pro" pitchFamily="34" charset="-122"/>
-                <a:cs typeface="Be Vietnam Pro" pitchFamily="34" charset="-120"/>
-              </a:rPr>
-              <a:t> chữ</a:t>
-            </a:r>
-            <a:r>
-              <a:rPr lang="en-US" sz="2100" dirty="0" spc="-1" kern="0">
-                <a:solidFill>
-                  <a:srgbClr val="D8D3C4"/>
-                </a:solidFill>
-                <a:latin typeface="Be Vietnam Pro" pitchFamily="34" charset="0"/>
-                <a:ea typeface="Be Vietnam Pro" pitchFamily="34" charset="-122"/>
-                <a:cs typeface="Be Vietnam Pro" pitchFamily="34" charset="-120"/>
-              </a:rPr>
-              <a:t> ký.</a:t>
-            </a:r>
-            <a:endParaRPr lang="en-US" sz="2100" dirty="0"/>
+              <a:t> chữ ký.</a:t>
+            </a:r>
+            <a:endParaRPr lang="en-US" sz="2550" dirty="0"/>
           </a:p>
         </p:txBody>
       </p:sp>
       <p:sp>
         <p:nvSpPr>
-          <p:cNvPr id="10" name="Shape 8"/>
-          <p:cNvSpPr/>
-          <p:nvPr/>
-        </p:nvSpPr>
-        <p:spPr>
-          <a:xfrm>
-            <a:off x="6477000" y="2571750"/>
-            <a:ext cx="5334000" cy="2209800"/>
+          <p:cNvPr id="8" name="Shape 6"/>
+          <p:cNvSpPr/>
+          <p:nvPr/>
+        </p:nvSpPr>
+        <p:spPr>
+          <a:xfrm>
+            <a:off x="5067300" y="2438400"/>
+            <a:ext cx="4000500" cy="2286000"/>
           </a:xfrm>
           <a:prstGeom prst="roundRect">
             <a:avLst>
-              <a:gd name="adj" fmla="val 11207"/>
+              <a:gd name="adj" fmla="val 9167"/>
             </a:avLst>
           </a:prstGeom>
           <a:solidFill>
@@ -4379,14 +4325,14 @@
       </p:sp>
       <p:sp>
         <p:nvSpPr>
-          <p:cNvPr id="11" name="Connector line-1792369924358-989425719"/>
-          <p:cNvSpPr/>
-          <p:nvPr/>
-        </p:nvSpPr>
-        <p:spPr>
-          <a:xfrm>
-            <a:off x="6724650" y="2819400"/>
-            <a:ext cx="4838700" cy="0"/>
+          <p:cNvPr id="9" name="Connector line-1792390670793-62651083"/>
+          <p:cNvSpPr/>
+          <p:nvPr/>
+        </p:nvSpPr>
+        <p:spPr>
+          <a:xfrm>
+            <a:off x="5314950" y="2686050"/>
+            <a:ext cx="3505200" cy="0"/>
           </a:xfrm>
           <a:prstGeom prst="line">
             <a:avLst/>
@@ -4404,13 +4350,13 @@
       </p:sp>
       <p:sp>
         <p:nvSpPr>
-          <p:cNvPr id="12" name="Shape 10"/>
-          <p:cNvSpPr/>
-          <p:nvPr/>
-        </p:nvSpPr>
-        <p:spPr>
-          <a:xfrm>
-            <a:off x="6648450" y="2743200"/>
+          <p:cNvPr id="10" name="Shape 8"/>
+          <p:cNvSpPr/>
+          <p:nvPr/>
+        </p:nvSpPr>
+        <p:spPr>
+          <a:xfrm>
+            <a:off x="5238750" y="2609850"/>
             <a:ext cx="152400" cy="152400"/>
           </a:xfrm>
           <a:prstGeom prst="ellipse">
@@ -4429,14 +4375,14 @@
       </p:sp>
       <p:sp>
         <p:nvSpPr>
-          <p:cNvPr id="13" name="Text 11"/>
-          <p:cNvSpPr/>
-          <p:nvPr/>
-        </p:nvSpPr>
-        <p:spPr>
-          <a:xfrm>
-            <a:off x="6724650" y="3009900"/>
-            <a:ext cx="4762500" cy="647700"/>
+          <p:cNvPr id="11" name="Text 9"/>
+          <p:cNvSpPr/>
+          <p:nvPr/>
+        </p:nvSpPr>
+        <p:spPr>
+          <a:xfrm>
+            <a:off x="5334000" y="2914650"/>
+            <a:ext cx="3467100" cy="1714500"/>
           </a:xfrm>
           <a:prstGeom prst="rect">
             <a:avLst/>
@@ -4445,117 +4391,85 @@
           <a:ln/>
         </p:spPr>
         <p:txBody>
-          <a:bodyPr wrap="square" lIns="0" tIns="0" rIns="0" bIns="0" rtlCol="0" anchor="t"/>
-          <a:lstStyle/>
-          <a:p>
-            <a:pPr algn="l" indent="0" marL="0">
-              <a:buNone/>
-            </a:pPr>
-            <a:r>
-              <a:rPr lang="en-US" sz="3900" dirty="0" spc="-3" kern="0">
-                <a:solidFill>
-                  <a:srgbClr val="FFB454"/>
-                </a:solidFill>
-                <a:latin typeface="Bricolage Grotesque ExtraBold" pitchFamily="34" charset="0"/>
-                <a:ea typeface="Bricolage Grotesque ExtraBold" pitchFamily="34" charset="-122"/>
-                <a:cs typeface="Bricolage Grotesque ExtraBold" pitchFamily="34" charset="-120"/>
-              </a:rPr>
-              <a:t>JSON</a:t>
-            </a:r>
-            <a:endParaRPr lang="en-US" sz="3900" dirty="0"/>
-          </a:p>
-        </p:txBody>
-      </p:sp>
-      <p:sp>
-        <p:nvSpPr>
-          <p:cNvPr id="14" name="Text 12"/>
-          <p:cNvSpPr/>
-          <p:nvPr/>
-        </p:nvSpPr>
-        <p:spPr>
-          <a:xfrm>
-            <a:off x="6724650" y="3657600"/>
-            <a:ext cx="4857750" cy="285750"/>
-          </a:xfrm>
-          <a:prstGeom prst="rect">
-            <a:avLst/>
-          </a:prstGeom>
-          <a:noFill/>
-          <a:ln/>
-        </p:spPr>
-        <p:txBody>
-          <a:bodyPr wrap="square" lIns="0" tIns="0" rIns="0" bIns="0" rtlCol="0" anchor="t"/>
-          <a:lstStyle/>
-          <a:p>
-            <a:pPr algn="l" indent="0" marL="0">
-              <a:buNone/>
-            </a:pPr>
-            <a:r>
-              <a:rPr lang="en-US" sz="1650" dirty="0" spc="-5" kern="0">
-                <a:solidFill>
-                  <a:srgbClr val="9A98A0"/>
-                </a:solidFill>
-                <a:latin typeface="Be Vietnam Pro" pitchFamily="34" charset="0"/>
-                <a:ea typeface="Be Vietnam Pro" pitchFamily="34" charset="-122"/>
-                <a:cs typeface="Be Vietnam Pro" pitchFamily="34" charset="-120"/>
-              </a:rPr>
-              <a:t>JavaScript</a:t>
-            </a:r>
-            <a:r>
-              <a:rPr lang="en-US" sz="1650" dirty="0" spc="-9" kern="0">
-                <a:solidFill>
-                  <a:srgbClr val="9A98A0"/>
-                </a:solidFill>
-                <a:latin typeface="Be Vietnam Pro" pitchFamily="34" charset="0"/>
-                <a:ea typeface="Be Vietnam Pro" pitchFamily="34" charset="-122"/>
-                <a:cs typeface="Be Vietnam Pro" pitchFamily="34" charset="-120"/>
-              </a:rPr>
-              <a:t> Object</a:t>
-            </a:r>
-            <a:r>
-              <a:rPr lang="en-US" sz="1650" dirty="0" spc="-10" kern="0">
-                <a:solidFill>
-                  <a:srgbClr val="9A98A0"/>
-                </a:solidFill>
-                <a:latin typeface="Be Vietnam Pro" pitchFamily="34" charset="0"/>
-                <a:ea typeface="Be Vietnam Pro" pitchFamily="34" charset="-122"/>
-                <a:cs typeface="Be Vietnam Pro" pitchFamily="34" charset="-120"/>
-              </a:rPr>
-              <a:t> Notation</a:t>
-            </a:r>
-            <a:endParaRPr lang="en-US" sz="1650" dirty="0"/>
-          </a:p>
-        </p:txBody>
-      </p:sp>
-      <p:sp>
-        <p:nvSpPr>
-          <p:cNvPr id="15" name="Text 13"/>
-          <p:cNvSpPr/>
-          <p:nvPr/>
-        </p:nvSpPr>
-        <p:spPr>
-          <a:xfrm>
-            <a:off x="6724650" y="3962400"/>
-            <a:ext cx="4857750" cy="723900"/>
-          </a:xfrm>
-          <a:prstGeom prst="rect">
-            <a:avLst/>
-          </a:prstGeom>
-          <a:noFill/>
-          <a:ln/>
-        </p:spPr>
-        <p:txBody>
-          <a:bodyPr wrap="square" lIns="0" tIns="11335" rIns="0" bIns="-11335" rtlCol="0" anchor="t"/>
+          <a:bodyPr wrap="square" lIns="0" tIns="16192" rIns="0" bIns="-16192" rtlCol="0" anchor="t"/>
           <a:lstStyle/>
           <a:p>
             <a:pPr algn="l" indent="0" marL="0">
               <a:lnSpc>
-                <a:spcPts val="2730"/>
+                <a:spcPts val="2805"/>
+              </a:lnSpc>
+              <a:spcAft>
+                <a:spcPts val="600"/>
+              </a:spcAft>
+              <a:buNone/>
+            </a:pPr>
+            <a:r>
+              <a:rPr lang="en-US" sz="2550" dirty="0" spc="-1" kern="0">
+                <a:solidFill>
+                  <a:srgbClr val="FFB454"/>
+                </a:solidFill>
+                <a:latin typeface="Bricolage Grotesque ExtraBold" pitchFamily="34" charset="0"/>
+                <a:ea typeface="Bricolage Grotesque ExtraBold" pitchFamily="34" charset="-122"/>
+                <a:cs typeface="Bricolage Grotesque ExtraBold" pitchFamily="34" charset="-120"/>
+              </a:rPr>
+              <a:t>JSON</a:t>
+            </a:r>
+            <a:endParaRPr lang="en-US" sz="2550" dirty="0"/>
+          </a:p>
+          <a:p>
+            <a:pPr algn="l" indent="0" marL="0">
+              <a:lnSpc>
+                <a:spcPts val="2145"/>
+              </a:lnSpc>
+              <a:spcAft>
+                <a:spcPts val="600"/>
+              </a:spcAft>
+              <a:buNone/>
+            </a:pPr>
+            <a:r>
+              <a:rPr lang="en-US" sz="1650" dirty="0" spc="-5" kern="0">
+                <a:solidFill>
+                  <a:srgbClr val="9A98A0"/>
+                </a:solidFill>
+                <a:latin typeface="Be Vietnam Pro" pitchFamily="34" charset="0"/>
+                <a:ea typeface="Be Vietnam Pro" pitchFamily="34" charset="-122"/>
+                <a:cs typeface="Be Vietnam Pro" pitchFamily="34" charset="-120"/>
+              </a:rPr>
+              <a:t>JavaScript</a:t>
+            </a:r>
+            <a:r>
+              <a:rPr lang="en-US" sz="1650" dirty="0" spc="-9" kern="0">
+                <a:solidFill>
+                  <a:srgbClr val="9A98A0"/>
+                </a:solidFill>
+                <a:latin typeface="Be Vietnam Pro" pitchFamily="34" charset="0"/>
+                <a:ea typeface="Be Vietnam Pro" pitchFamily="34" charset="-122"/>
+                <a:cs typeface="Be Vietnam Pro" pitchFamily="34" charset="-120"/>
+              </a:rPr>
+              <a:t> Object</a:t>
+            </a:r>
+            <a:r>
+              <a:rPr lang="en-US" sz="1650" dirty="0" spc="-10" kern="0">
+                <a:solidFill>
+                  <a:srgbClr val="9A98A0"/>
+                </a:solidFill>
+                <a:latin typeface="Be Vietnam Pro" pitchFamily="34" charset="0"/>
+                <a:ea typeface="Be Vietnam Pro" pitchFamily="34" charset="-122"/>
+                <a:cs typeface="Be Vietnam Pro" pitchFamily="34" charset="-120"/>
+              </a:rPr>
+              <a:t> Notation</a:t>
+            </a:r>
+            <a:endParaRPr lang="en-US" sz="2550" dirty="0"/>
+          </a:p>
+          <a:p>
+            <a:pPr algn="l" indent="0" marL="0">
+              <a:lnSpc>
+                <a:spcPts val="2145"/>
               </a:lnSpc>
               <a:buNone/>
             </a:pPr>
             <a:r>
-              <a:rPr lang="en-US" sz="2100" dirty="0" spc="3" kern="0">
+              <a:rPr lang="en-US" sz="1650" dirty="0" spc="-25" kern="0">
                 <a:solidFill>
                   <a:srgbClr val="D8D3C4"/>
                 </a:solidFill>
@@ -4563,10 +4477,10 @@
                 <a:ea typeface="Be Vietnam Pro" pitchFamily="34" charset="-122"/>
                 <a:cs typeface="Be Vietnam Pro" pitchFamily="34" charset="-120"/>
               </a:rPr>
-              <a:t>Định</a:t>
-            </a:r>
-            <a:r>
-              <a:rPr lang="en-US" sz="2100" dirty="0" spc="-2" kern="0">
+              <a:t>Văn</a:t>
+            </a:r>
+            <a:r>
+              <a:rPr lang="en-US" sz="1650" dirty="0" spc="-1" kern="0">
                 <a:solidFill>
                   <a:srgbClr val="D8D3C4"/>
                 </a:solidFill>
@@ -4574,10 +4488,10 @@
                 <a:ea typeface="Be Vietnam Pro" pitchFamily="34" charset="-122"/>
                 <a:cs typeface="Be Vietnam Pro" pitchFamily="34" charset="-120"/>
               </a:rPr>
-              <a:t> dạng</a:t>
-            </a:r>
-            <a:r>
-              <a:rPr lang="en-US" sz="2100" dirty="0" spc="-13" kern="0">
+              <a:t> bản</a:t>
+            </a:r>
+            <a:r>
+              <a:rPr lang="en-US" sz="1650" dirty="0" spc="-8" kern="0">
                 <a:solidFill>
                   <a:srgbClr val="D8D3C4"/>
                 </a:solidFill>
@@ -4585,10 +4499,10 @@
                 <a:ea typeface="Be Vietnam Pro" pitchFamily="34" charset="-122"/>
                 <a:cs typeface="Be Vietnam Pro" pitchFamily="34" charset="-120"/>
               </a:rPr>
-              <a:t> văn</a:t>
-            </a:r>
-            <a:r>
-              <a:rPr lang="en-US" sz="2100" dirty="0" spc="-5" kern="0">
+              <a:t> gồm</a:t>
+            </a:r>
+            <a:r>
+              <a:rPr lang="en-US" sz="1650" dirty="0" spc="2" kern="0">
                 <a:solidFill>
                   <a:srgbClr val="D8D3C4"/>
                 </a:solidFill>
@@ -4596,10 +4510,10 @@
                 <a:ea typeface="Be Vietnam Pro" pitchFamily="34" charset="-122"/>
                 <a:cs typeface="Be Vietnam Pro" pitchFamily="34" charset="-120"/>
               </a:rPr>
-              <a:t> bản</a:t>
-            </a:r>
-            <a:r>
-              <a:rPr lang="en-US" sz="2100" dirty="0" spc="-13" kern="0">
+              <a:t> cặp</a:t>
+            </a:r>
+            <a:r>
+              <a:rPr lang="en-US" sz="1650" dirty="0" spc="-6" kern="0">
                 <a:solidFill>
                   <a:srgbClr val="D8D3C4"/>
                 </a:solidFill>
@@ -4607,10 +4521,10 @@
                 <a:ea typeface="Be Vietnam Pro" pitchFamily="34" charset="-122"/>
                 <a:cs typeface="Be Vietnam Pro" pitchFamily="34" charset="-120"/>
               </a:rPr>
-              <a:t> gồm</a:t>
-            </a:r>
-            <a:r>
-              <a:rPr lang="en-US" sz="2100" dirty="0" spc="-3" kern="0">
+              <a:t> tên</a:t>
+            </a:r>
+            <a:r>
+              <a:rPr lang="en-US" sz="1650" dirty="0" spc="-8" kern="0">
                 <a:solidFill>
                   <a:srgbClr val="D8D3C4"/>
                 </a:solidFill>
@@ -4618,10 +4532,10 @@
                 <a:ea typeface="Be Vietnam Pro" pitchFamily="34" charset="-122"/>
                 <a:cs typeface="Be Vietnam Pro" pitchFamily="34" charset="-120"/>
               </a:rPr>
-              <a:t> cặp</a:t>
-            </a:r>
-            <a:r>
-              <a:rPr lang="en-US" sz="2100" dirty="0" spc="-10" kern="0">
+              <a:t> và</a:t>
+            </a:r>
+            <a:r>
+              <a:rPr lang="en-US" sz="1650" dirty="0" spc="1" kern="0">
                 <a:solidFill>
                   <a:srgbClr val="D8D3C4"/>
                 </a:solidFill>
@@ -4629,10 +4543,10 @@
                 <a:ea typeface="Be Vietnam Pro" pitchFamily="34" charset="-122"/>
                 <a:cs typeface="Be Vietnam Pro" pitchFamily="34" charset="-120"/>
               </a:rPr>
-              <a:t> tên</a:t>
-            </a:r>
-            <a:r>
-              <a:rPr lang="en-US" sz="2100" dirty="0" spc="-18" kern="0">
+              <a:t> giá</a:t>
+            </a:r>
+            <a:r>
+              <a:rPr lang="en-US" sz="1650" dirty="0" spc="9" kern="0">
                 <a:solidFill>
                   <a:srgbClr val="D8D3C4"/>
                 </a:solidFill>
@@ -4640,48 +4554,26 @@
                 <a:ea typeface="Be Vietnam Pro" pitchFamily="34" charset="-122"/>
                 <a:cs typeface="Be Vietnam Pro" pitchFamily="34" charset="-120"/>
               </a:rPr>
-              <a:t> và</a:t>
-            </a:r>
-            <a:r>
-              <a:rPr lang="en-US" sz="2100" dirty="0" spc="-1" kern="0">
-                <a:solidFill>
-                  <a:srgbClr val="D8D3C4"/>
-                </a:solidFill>
-                <a:latin typeface="Be Vietnam Pro" pitchFamily="34" charset="0"/>
-                <a:ea typeface="Be Vietnam Pro" pitchFamily="34" charset="-122"/>
-                <a:cs typeface="Be Vietnam Pro" pitchFamily="34" charset="-120"/>
-              </a:rPr>
-              <a:t> giá</a:t>
-            </a:r>
-            <a:r>
-              <a:rPr lang="en-US" sz="2100" dirty="0" spc="8" kern="0">
-                <a:solidFill>
-                  <a:srgbClr val="D8D3C4"/>
-                </a:solidFill>
-                <a:latin typeface="Be Vietnam Pro" pitchFamily="34" charset="0"/>
-                <a:ea typeface="Be Vietnam Pro" pitchFamily="34" charset="-122"/>
-                <a:cs typeface="Be Vietnam Pro" pitchFamily="34" charset="-120"/>
-              </a:rPr>
               <a:t> trị.</a:t>
             </a:r>
-            <a:endParaRPr lang="en-US" sz="2100" dirty="0"/>
+            <a:endParaRPr lang="en-US" sz="2550" dirty="0"/>
           </a:p>
         </p:txBody>
       </p:sp>
       <p:sp>
         <p:nvSpPr>
-          <p:cNvPr id="16" name="Shape 14"/>
-          <p:cNvSpPr/>
-          <p:nvPr/>
-        </p:nvSpPr>
-        <p:spPr>
-          <a:xfrm>
-            <a:off x="12039600" y="2571750"/>
-            <a:ext cx="5334000" cy="2209800"/>
+          <p:cNvPr id="12" name="Shape 10"/>
+          <p:cNvSpPr/>
+          <p:nvPr/>
+        </p:nvSpPr>
+        <p:spPr>
+          <a:xfrm>
+            <a:off x="9220200" y="2438400"/>
+            <a:ext cx="4000500" cy="2286000"/>
           </a:xfrm>
           <a:prstGeom prst="roundRect">
             <a:avLst>
-              <a:gd name="adj" fmla="val 11207"/>
+              <a:gd name="adj" fmla="val 9167"/>
             </a:avLst>
           </a:prstGeom>
           <a:solidFill>
@@ -4692,14 +4584,14 @@
       </p:sp>
       <p:sp>
         <p:nvSpPr>
-          <p:cNvPr id="17" name="Connector line-1792369924368-949015484"/>
-          <p:cNvSpPr/>
-          <p:nvPr/>
-        </p:nvSpPr>
-        <p:spPr>
-          <a:xfrm>
-            <a:off x="12287250" y="2819400"/>
-            <a:ext cx="4838700" cy="0"/>
+          <p:cNvPr id="13" name="Connector line-1792390670799-440082187"/>
+          <p:cNvSpPr/>
+          <p:nvPr/>
+        </p:nvSpPr>
+        <p:spPr>
+          <a:xfrm>
+            <a:off x="9467850" y="2686050"/>
+            <a:ext cx="3505200" cy="0"/>
           </a:xfrm>
           <a:prstGeom prst="line">
             <a:avLst/>
@@ -4717,13 +4609,13 @@
       </p:sp>
       <p:sp>
         <p:nvSpPr>
-          <p:cNvPr id="18" name="Shape 16"/>
-          <p:cNvSpPr/>
-          <p:nvPr/>
-        </p:nvSpPr>
-        <p:spPr>
-          <a:xfrm>
-            <a:off x="12211050" y="2743200"/>
+          <p:cNvPr id="14" name="Shape 12"/>
+          <p:cNvSpPr/>
+          <p:nvPr/>
+        </p:nvSpPr>
+        <p:spPr>
+          <a:xfrm>
+            <a:off x="9391650" y="2609850"/>
             <a:ext cx="152400" cy="152400"/>
           </a:xfrm>
           <a:prstGeom prst="ellipse">
@@ -4742,14 +4634,14 @@
       </p:sp>
       <p:sp>
         <p:nvSpPr>
-          <p:cNvPr id="19" name="Text 17"/>
-          <p:cNvSpPr/>
-          <p:nvPr/>
-        </p:nvSpPr>
-        <p:spPr>
-          <a:xfrm>
-            <a:off x="12287250" y="3009900"/>
-            <a:ext cx="4762500" cy="647700"/>
+          <p:cNvPr id="15" name="Text 13"/>
+          <p:cNvSpPr/>
+          <p:nvPr/>
+        </p:nvSpPr>
+        <p:spPr>
+          <a:xfrm>
+            <a:off x="9486900" y="2914650"/>
+            <a:ext cx="3467100" cy="1714500"/>
           </a:xfrm>
           <a:prstGeom prst="rect">
             <a:avLst/>
@@ -4758,106 +4650,74 @@
           <a:ln/>
         </p:spPr>
         <p:txBody>
-          <a:bodyPr wrap="square" lIns="0" tIns="0" rIns="0" bIns="0" rtlCol="0" anchor="t"/>
-          <a:lstStyle/>
-          <a:p>
-            <a:pPr algn="l" indent="0" marL="0">
-              <a:buNone/>
-            </a:pPr>
-            <a:r>
-              <a:rPr lang="en-US" sz="3900" dirty="0" spc="2" kern="0">
-                <a:solidFill>
-                  <a:srgbClr val="7C93FF"/>
-                </a:solidFill>
-                <a:latin typeface="Bricolage Grotesque ExtraBold" pitchFamily="34" charset="0"/>
-                <a:ea typeface="Bricolage Grotesque ExtraBold" pitchFamily="34" charset="-122"/>
-                <a:cs typeface="Bricolage Grotesque ExtraBold" pitchFamily="34" charset="-120"/>
-              </a:rPr>
-              <a:t>SSO</a:t>
-            </a:r>
-            <a:endParaRPr lang="en-US" sz="3900" dirty="0"/>
-          </a:p>
-        </p:txBody>
-      </p:sp>
-      <p:sp>
-        <p:nvSpPr>
-          <p:cNvPr id="20" name="Text 18"/>
-          <p:cNvSpPr/>
-          <p:nvPr/>
-        </p:nvSpPr>
-        <p:spPr>
-          <a:xfrm>
-            <a:off x="12287250" y="3657600"/>
-            <a:ext cx="4857750" cy="285750"/>
-          </a:xfrm>
-          <a:prstGeom prst="rect">
-            <a:avLst/>
-          </a:prstGeom>
-          <a:noFill/>
-          <a:ln/>
-        </p:spPr>
-        <p:txBody>
-          <a:bodyPr wrap="square" lIns="0" tIns="0" rIns="0" bIns="0" rtlCol="0" anchor="t"/>
-          <a:lstStyle/>
-          <a:p>
-            <a:pPr algn="l" indent="0" marL="0">
-              <a:buNone/>
-            </a:pPr>
-            <a:r>
-              <a:rPr lang="en-US" sz="1650" dirty="0" spc="-2" kern="0">
-                <a:solidFill>
-                  <a:srgbClr val="9A98A0"/>
-                </a:solidFill>
-                <a:latin typeface="Be Vietnam Pro" pitchFamily="34" charset="0"/>
-                <a:ea typeface="Be Vietnam Pro" pitchFamily="34" charset="-122"/>
-                <a:cs typeface="Be Vietnam Pro" pitchFamily="34" charset="-120"/>
-              </a:rPr>
-              <a:t>Single</a:t>
-            </a:r>
-            <a:r>
-              <a:rPr lang="en-US" sz="1650" dirty="0" spc="-1" kern="0">
-                <a:solidFill>
-                  <a:srgbClr val="9A98A0"/>
-                </a:solidFill>
-                <a:latin typeface="Be Vietnam Pro" pitchFamily="34" charset="0"/>
-                <a:ea typeface="Be Vietnam Pro" pitchFamily="34" charset="-122"/>
-                <a:cs typeface="Be Vietnam Pro" pitchFamily="34" charset="-120"/>
-              </a:rPr>
-              <a:t> Sign-On</a:t>
-            </a:r>
-            <a:endParaRPr lang="en-US" sz="1650" dirty="0"/>
-          </a:p>
-        </p:txBody>
-      </p:sp>
-      <p:sp>
-        <p:nvSpPr>
-          <p:cNvPr id="21" name="Text 19"/>
-          <p:cNvSpPr/>
-          <p:nvPr/>
-        </p:nvSpPr>
-        <p:spPr>
-          <a:xfrm>
-            <a:off x="12287250" y="3962400"/>
-            <a:ext cx="4857750" cy="723900"/>
-          </a:xfrm>
-          <a:prstGeom prst="rect">
-            <a:avLst/>
-          </a:prstGeom>
-          <a:noFill/>
-          <a:ln/>
-        </p:spPr>
-        <p:txBody>
-          <a:bodyPr wrap="square" lIns="0" tIns="11335" rIns="0" bIns="-11335" rtlCol="0" anchor="t"/>
+          <a:bodyPr wrap="square" lIns="0" tIns="16192" rIns="0" bIns="-16192" rtlCol="0" anchor="t"/>
           <a:lstStyle/>
           <a:p>
             <a:pPr algn="l" indent="0" marL="0">
               <a:lnSpc>
-                <a:spcPts val="2730"/>
+                <a:spcPts val="2805"/>
+              </a:lnSpc>
+              <a:spcAft>
+                <a:spcPts val="600"/>
+              </a:spcAft>
+              <a:buNone/>
+            </a:pPr>
+            <a:r>
+              <a:rPr lang="en-US" sz="2550" dirty="0" spc="6" kern="0">
+                <a:solidFill>
+                  <a:srgbClr val="7C93FF"/>
+                </a:solidFill>
+                <a:latin typeface="Bricolage Grotesque ExtraBold" pitchFamily="34" charset="0"/>
+                <a:ea typeface="Bricolage Grotesque ExtraBold" pitchFamily="34" charset="-122"/>
+                <a:cs typeface="Bricolage Grotesque ExtraBold" pitchFamily="34" charset="-120"/>
+              </a:rPr>
+              <a:t>SSO</a:t>
+            </a:r>
+            <a:endParaRPr lang="en-US" sz="2550" dirty="0"/>
+          </a:p>
+          <a:p>
+            <a:pPr algn="l" indent="0" marL="0">
+              <a:lnSpc>
+                <a:spcPts val="2145"/>
+              </a:lnSpc>
+              <a:spcAft>
+                <a:spcPts val="600"/>
+              </a:spcAft>
+              <a:buNone/>
+            </a:pPr>
+            <a:r>
+              <a:rPr lang="en-US" sz="1650" dirty="0" spc="-2" kern="0">
+                <a:solidFill>
+                  <a:srgbClr val="9A98A0"/>
+                </a:solidFill>
+                <a:latin typeface="Be Vietnam Pro" pitchFamily="34" charset="0"/>
+                <a:ea typeface="Be Vietnam Pro" pitchFamily="34" charset="-122"/>
+                <a:cs typeface="Be Vietnam Pro" pitchFamily="34" charset="-120"/>
+              </a:rPr>
+              <a:t>Single</a:t>
+            </a:r>
+            <a:r>
+              <a:rPr lang="en-US" sz="1650" dirty="0" spc="-1" kern="0">
+                <a:solidFill>
+                  <a:srgbClr val="9A98A0"/>
+                </a:solidFill>
+                <a:latin typeface="Be Vietnam Pro" pitchFamily="34" charset="0"/>
+                <a:ea typeface="Be Vietnam Pro" pitchFamily="34" charset="-122"/>
+                <a:cs typeface="Be Vietnam Pro" pitchFamily="34" charset="-120"/>
+              </a:rPr>
+              <a:t> Sign-On</a:t>
+            </a:r>
+            <a:endParaRPr lang="en-US" sz="2550" dirty="0"/>
+          </a:p>
+          <a:p>
+            <a:pPr algn="l" indent="0" marL="0">
+              <a:lnSpc>
+                <a:spcPts val="2145"/>
               </a:lnSpc>
               <a:buNone/>
             </a:pPr>
             <a:r>
-              <a:rPr lang="en-US" sz="2100" dirty="0" spc="1" kern="0">
+              <a:rPr lang="en-US" sz="1650" dirty="0" spc="-1" kern="0">
                 <a:solidFill>
                   <a:srgbClr val="D8D3C4"/>
                 </a:solidFill>
@@ -4868,7 +4728,7 @@
               <a:t>Đăng</a:t>
             </a:r>
             <a:r>
-              <a:rPr lang="en-US" sz="2100" dirty="0" spc="-2" kern="0">
+              <a:rPr lang="en-US" sz="1650" dirty="0" spc="1" kern="0">
                 <a:solidFill>
                   <a:srgbClr val="D8D3C4"/>
                 </a:solidFill>
@@ -4879,7 +4739,7 @@
               <a:t> nhập</a:t>
             </a:r>
             <a:r>
-              <a:rPr lang="en-US" sz="2100" dirty="0" spc="-8" kern="0">
+              <a:rPr lang="en-US" sz="1650" dirty="0" spc="-2" kern="0">
                 <a:solidFill>
                   <a:srgbClr val="D8D3C4"/>
                 </a:solidFill>
@@ -4890,7 +4750,7 @@
               <a:t> một</a:t>
             </a:r>
             <a:r>
-              <a:rPr lang="en-US" sz="2100" dirty="0" spc="-2" kern="0">
+              <a:rPr lang="en-US" sz="1650" dirty="0" spc="0" kern="0">
                 <a:solidFill>
                   <a:srgbClr val="D8D3C4"/>
                 </a:solidFill>
@@ -4901,7 +4761,7 @@
               <a:t> lần,</a:t>
             </a:r>
             <a:r>
-              <a:rPr lang="en-US" sz="2100" dirty="0" spc="0" kern="0">
+              <a:rPr lang="en-US" sz="1650" dirty="0" spc="-1" kern="0">
                 <a:solidFill>
                   <a:srgbClr val="D8D3C4"/>
                 </a:solidFill>
@@ -4912,7 +4772,7 @@
               <a:t> dùng</a:t>
             </a:r>
             <a:r>
-              <a:rPr lang="en-US" sz="2100" dirty="0" spc="1" kern="0">
+              <a:rPr lang="en-US" sz="1650" dirty="0" spc="0" kern="0">
                 <a:solidFill>
                   <a:srgbClr val="D8D3C4"/>
                 </a:solidFill>
@@ -4923,7 +4783,7 @@
               <a:t> nhiều</a:t>
             </a:r>
             <a:r>
-              <a:rPr lang="en-US" sz="2100" dirty="0" spc="22" kern="0">
+              <a:rPr lang="en-US" sz="1650" dirty="0" spc="16" kern="0">
                 <a:solidFill>
                   <a:srgbClr val="D8D3C4"/>
                 </a:solidFill>
@@ -4934,7 +4794,7 @@
               <a:t> ứng</a:t>
             </a:r>
             <a:r>
-              <a:rPr lang="en-US" sz="2100" dirty="0" spc="-1" kern="0">
+              <a:rPr lang="en-US" sz="1650" dirty="0" spc="0" kern="0">
                 <a:solidFill>
                   <a:srgbClr val="D8D3C4"/>
                 </a:solidFill>
@@ -4944,24 +4804,24 @@
               </a:rPr>
               <a:t> dụng.</a:t>
             </a:r>
-            <a:endParaRPr lang="en-US" sz="2100" dirty="0"/>
+            <a:endParaRPr lang="en-US" sz="2550" dirty="0"/>
           </a:p>
         </p:txBody>
       </p:sp>
       <p:sp>
         <p:nvSpPr>
-          <p:cNvPr id="22" name="Shape 20"/>
-          <p:cNvSpPr/>
-          <p:nvPr/>
-        </p:nvSpPr>
-        <p:spPr>
-          <a:xfrm>
-            <a:off x="914400" y="5010150"/>
-            <a:ext cx="5334000" cy="2209800"/>
+          <p:cNvPr id="16" name="Shape 14"/>
+          <p:cNvSpPr/>
+          <p:nvPr/>
+        </p:nvSpPr>
+        <p:spPr>
+          <a:xfrm>
+            <a:off x="13373100" y="2438400"/>
+            <a:ext cx="4000500" cy="2286000"/>
           </a:xfrm>
           <a:prstGeom prst="roundRect">
             <a:avLst>
-              <a:gd name="adj" fmla="val 11207"/>
+              <a:gd name="adj" fmla="val 9167"/>
             </a:avLst>
           </a:prstGeom>
           <a:solidFill>
@@ -4972,14 +4832,14 @@
       </p:sp>
       <p:sp>
         <p:nvSpPr>
-          <p:cNvPr id="23" name="Connector line-1792369924377-339604691"/>
-          <p:cNvSpPr/>
-          <p:nvPr/>
-        </p:nvSpPr>
-        <p:spPr>
-          <a:xfrm>
-            <a:off x="1162050" y="5257800"/>
-            <a:ext cx="4838700" cy="0"/>
+          <p:cNvPr id="17" name="Connector line-1792390670803-412735607"/>
+          <p:cNvSpPr/>
+          <p:nvPr/>
+        </p:nvSpPr>
+        <p:spPr>
+          <a:xfrm>
+            <a:off x="13620750" y="2686050"/>
+            <a:ext cx="3505200" cy="0"/>
           </a:xfrm>
           <a:prstGeom prst="line">
             <a:avLst/>
@@ -4997,13 +4857,13 @@
       </p:sp>
       <p:sp>
         <p:nvSpPr>
-          <p:cNvPr id="24" name="Shape 22"/>
-          <p:cNvSpPr/>
-          <p:nvPr/>
-        </p:nvSpPr>
-        <p:spPr>
-          <a:xfrm>
-            <a:off x="1085850" y="5181600"/>
+          <p:cNvPr id="18" name="Shape 16"/>
+          <p:cNvSpPr/>
+          <p:nvPr/>
+        </p:nvSpPr>
+        <p:spPr>
+          <a:xfrm>
+            <a:off x="13544550" y="2609850"/>
             <a:ext cx="152400" cy="152400"/>
           </a:xfrm>
           <a:prstGeom prst="ellipse">
@@ -5022,14 +4882,14 @@
       </p:sp>
       <p:sp>
         <p:nvSpPr>
-          <p:cNvPr id="25" name="Text 23"/>
-          <p:cNvSpPr/>
-          <p:nvPr/>
-        </p:nvSpPr>
-        <p:spPr>
-          <a:xfrm>
-            <a:off x="1162050" y="5448300"/>
-            <a:ext cx="4762500" cy="647700"/>
+          <p:cNvPr id="19" name="Text 17"/>
+          <p:cNvSpPr/>
+          <p:nvPr/>
+        </p:nvSpPr>
+        <p:spPr>
+          <a:xfrm>
+            <a:off x="13639800" y="2914650"/>
+            <a:ext cx="3467100" cy="1714500"/>
           </a:xfrm>
           <a:prstGeom prst="rect">
             <a:avLst/>
@@ -5038,106 +4898,74 @@
           <a:ln/>
         </p:spPr>
         <p:txBody>
-          <a:bodyPr wrap="square" lIns="0" tIns="0" rIns="0" bIns="0" rtlCol="0" anchor="t"/>
-          <a:lstStyle/>
-          <a:p>
-            <a:pPr algn="l" indent="0" marL="0">
-              <a:buNone/>
-            </a:pPr>
-            <a:r>
-              <a:rPr lang="en-US" sz="3900" dirty="0" spc="-50" kern="0">
-                <a:solidFill>
-                  <a:srgbClr val="F3EEE3"/>
-                </a:solidFill>
-                <a:latin typeface="Bricolage Grotesque ExtraBold" pitchFamily="34" charset="0"/>
-                <a:ea typeface="Bricolage Grotesque ExtraBold" pitchFamily="34" charset="-122"/>
-                <a:cs typeface="Bricolage Grotesque ExtraBold" pitchFamily="34" charset="-120"/>
-              </a:rPr>
-              <a:t>OAuth</a:t>
-            </a:r>
-            <a:endParaRPr lang="en-US" sz="3900" dirty="0"/>
-          </a:p>
-        </p:txBody>
-      </p:sp>
-      <p:sp>
-        <p:nvSpPr>
-          <p:cNvPr id="26" name="Text 24"/>
-          <p:cNvSpPr/>
-          <p:nvPr/>
-        </p:nvSpPr>
-        <p:spPr>
-          <a:xfrm>
-            <a:off x="1162050" y="6096000"/>
-            <a:ext cx="4857750" cy="285750"/>
-          </a:xfrm>
-          <a:prstGeom prst="rect">
-            <a:avLst/>
-          </a:prstGeom>
-          <a:noFill/>
-          <a:ln/>
-        </p:spPr>
-        <p:txBody>
-          <a:bodyPr wrap="square" lIns="0" tIns="0" rIns="0" bIns="0" rtlCol="0" anchor="t"/>
-          <a:lstStyle/>
-          <a:p>
-            <a:pPr algn="l" indent="0" marL="0">
-              <a:buNone/>
-            </a:pPr>
-            <a:r>
-              <a:rPr lang="en-US" sz="1650" dirty="0" spc="-3" kern="0">
-                <a:solidFill>
-                  <a:srgbClr val="9A98A0"/>
-                </a:solidFill>
-                <a:latin typeface="Be Vietnam Pro" pitchFamily="34" charset="0"/>
-                <a:ea typeface="Be Vietnam Pro" pitchFamily="34" charset="-122"/>
-                <a:cs typeface="Be Vietnam Pro" pitchFamily="34" charset="-120"/>
-              </a:rPr>
-              <a:t>Open</a:t>
-            </a:r>
-            <a:r>
-              <a:rPr lang="en-US" sz="1650" dirty="0" spc="-2" kern="0">
-                <a:solidFill>
-                  <a:srgbClr val="9A98A0"/>
-                </a:solidFill>
-                <a:latin typeface="Be Vietnam Pro" pitchFamily="34" charset="0"/>
-                <a:ea typeface="Be Vietnam Pro" pitchFamily="34" charset="-122"/>
-                <a:cs typeface="Be Vietnam Pro" pitchFamily="34" charset="-120"/>
-              </a:rPr>
-              <a:t> AUTHorization</a:t>
-            </a:r>
-            <a:endParaRPr lang="en-US" sz="1650" dirty="0"/>
-          </a:p>
-        </p:txBody>
-      </p:sp>
-      <p:sp>
-        <p:nvSpPr>
-          <p:cNvPr id="27" name="Text 25"/>
-          <p:cNvSpPr/>
-          <p:nvPr/>
-        </p:nvSpPr>
-        <p:spPr>
-          <a:xfrm>
-            <a:off x="1162050" y="6400800"/>
-            <a:ext cx="4857750" cy="723900"/>
-          </a:xfrm>
-          <a:prstGeom prst="rect">
-            <a:avLst/>
-          </a:prstGeom>
-          <a:noFill/>
-          <a:ln/>
-        </p:spPr>
-        <p:txBody>
-          <a:bodyPr wrap="square" lIns="0" tIns="11335" rIns="0" bIns="-11335" rtlCol="0" anchor="t"/>
+          <a:bodyPr wrap="square" lIns="0" tIns="16192" rIns="0" bIns="-16192" rtlCol="0" anchor="t"/>
           <a:lstStyle/>
           <a:p>
             <a:pPr algn="l" indent="0" marL="0">
               <a:lnSpc>
-                <a:spcPts val="2730"/>
+                <a:spcPts val="2805"/>
+              </a:lnSpc>
+              <a:spcAft>
+                <a:spcPts val="600"/>
+              </a:spcAft>
+              <a:buNone/>
+            </a:pPr>
+            <a:r>
+              <a:rPr lang="en-US" sz="2550" dirty="0" spc="-33" kern="0">
+                <a:solidFill>
+                  <a:srgbClr val="F3EEE3"/>
+                </a:solidFill>
+                <a:latin typeface="Bricolage Grotesque ExtraBold" pitchFamily="34" charset="0"/>
+                <a:ea typeface="Bricolage Grotesque ExtraBold" pitchFamily="34" charset="-122"/>
+                <a:cs typeface="Bricolage Grotesque ExtraBold" pitchFamily="34" charset="-120"/>
+              </a:rPr>
+              <a:t>OAuth</a:t>
+            </a:r>
+            <a:endParaRPr lang="en-US" sz="2550" dirty="0"/>
+          </a:p>
+          <a:p>
+            <a:pPr algn="l" indent="0" marL="0">
+              <a:lnSpc>
+                <a:spcPts val="2145"/>
+              </a:lnSpc>
+              <a:spcAft>
+                <a:spcPts val="600"/>
+              </a:spcAft>
+              <a:buNone/>
+            </a:pPr>
+            <a:r>
+              <a:rPr lang="en-US" sz="1650" dirty="0" spc="-3" kern="0">
+                <a:solidFill>
+                  <a:srgbClr val="9A98A0"/>
+                </a:solidFill>
+                <a:latin typeface="Be Vietnam Pro" pitchFamily="34" charset="0"/>
+                <a:ea typeface="Be Vietnam Pro" pitchFamily="34" charset="-122"/>
+                <a:cs typeface="Be Vietnam Pro" pitchFamily="34" charset="-120"/>
+              </a:rPr>
+              <a:t>Open</a:t>
+            </a:r>
+            <a:r>
+              <a:rPr lang="en-US" sz="1650" dirty="0" spc="-2" kern="0">
+                <a:solidFill>
+                  <a:srgbClr val="9A98A0"/>
+                </a:solidFill>
+                <a:latin typeface="Be Vietnam Pro" pitchFamily="34" charset="0"/>
+                <a:ea typeface="Be Vietnam Pro" pitchFamily="34" charset="-122"/>
+                <a:cs typeface="Be Vietnam Pro" pitchFamily="34" charset="-120"/>
+              </a:rPr>
+              <a:t> AUTHorization</a:t>
+            </a:r>
+            <a:endParaRPr lang="en-US" sz="2550" dirty="0"/>
+          </a:p>
+          <a:p>
+            <a:pPr algn="l" indent="0" marL="0">
+              <a:lnSpc>
+                <a:spcPts val="2145"/>
               </a:lnSpc>
               <a:buNone/>
             </a:pPr>
             <a:r>
-              <a:rPr lang="en-US" sz="2100" dirty="0" spc="0" kern="0">
+              <a:rPr lang="en-US" sz="1650" dirty="0" spc="2" kern="0">
                 <a:solidFill>
                   <a:srgbClr val="D8D3C4"/>
                 </a:solidFill>
@@ -5145,10 +4973,10 @@
                 <a:ea typeface="Be Vietnam Pro" pitchFamily="34" charset="-122"/>
                 <a:cs typeface="Be Vietnam Pro" pitchFamily="34" charset="-120"/>
               </a:rPr>
-              <a:t>Cho</a:t>
-            </a:r>
-            <a:r>
-              <a:rPr lang="en-US" sz="2100" dirty="0" spc="22" kern="0">
+              <a:t>Ủy</a:t>
+            </a:r>
+            <a:r>
+              <a:rPr lang="en-US" sz="1650" dirty="0" spc="-9" kern="0">
                 <a:solidFill>
                   <a:srgbClr val="D8D3C4"/>
                 </a:solidFill>
@@ -5156,10 +4984,21 @@
                 <a:ea typeface="Be Vietnam Pro" pitchFamily="34" charset="-122"/>
                 <a:cs typeface="Be Vietnam Pro" pitchFamily="34" charset="-120"/>
               </a:rPr>
+              <a:t> quyền:</a:t>
+            </a:r>
+            <a:r>
+              <a:rPr lang="en-US" sz="1650" dirty="0" spc="17" kern="0">
+                <a:solidFill>
+                  <a:srgbClr val="D8D3C4"/>
+                </a:solidFill>
+                <a:latin typeface="Be Vietnam Pro" pitchFamily="34" charset="0"/>
+                <a:ea typeface="Be Vietnam Pro" pitchFamily="34" charset="-122"/>
+                <a:cs typeface="Be Vietnam Pro" pitchFamily="34" charset="-120"/>
+              </a:rPr>
               <a:t> ứng</a:t>
             </a:r>
             <a:r>
-              <a:rPr lang="en-US" sz="2100" dirty="0" spc="-1" kern="0">
+              <a:rPr lang="en-US" sz="1650" dirty="0" spc="0" kern="0">
                 <a:solidFill>
                   <a:srgbClr val="D8D3C4"/>
                 </a:solidFill>
@@ -5167,10 +5006,10 @@
                 <a:ea typeface="Be Vietnam Pro" pitchFamily="34" charset="-122"/>
                 <a:cs typeface="Be Vietnam Pro" pitchFamily="34" charset="-120"/>
               </a:rPr>
-              <a:t> dụng</a:t>
-            </a:r>
-            <a:r>
-              <a:rPr lang="en-US" sz="2100" dirty="0" spc="-2" kern="0">
+              <a:t> dụng làm việc</a:t>
+            </a:r>
+            <a:r>
+              <a:rPr lang="en-US" sz="1650" dirty="0" spc="-3" kern="0">
                 <a:solidFill>
                   <a:srgbClr val="D8D3C4"/>
                 </a:solidFill>
@@ -5178,81 +5017,26 @@
                 <a:ea typeface="Be Vietnam Pro" pitchFamily="34" charset="-122"/>
                 <a:cs typeface="Be Vietnam Pro" pitchFamily="34" charset="-120"/>
               </a:rPr>
-              <a:t> làm</a:t>
-            </a:r>
-            <a:r>
-              <a:rPr lang="en-US" sz="2100" dirty="0" spc="-8" kern="0">
-                <a:solidFill>
-                  <a:srgbClr val="D8D3C4"/>
-                </a:solidFill>
-                <a:latin typeface="Be Vietnam Pro" pitchFamily="34" charset="0"/>
-                <a:ea typeface="Be Vietnam Pro" pitchFamily="34" charset="-122"/>
-                <a:cs typeface="Be Vietnam Pro" pitchFamily="34" charset="-120"/>
-              </a:rPr>
-              <a:t> một</a:t>
-            </a:r>
-            <a:r>
-              <a:rPr lang="en-US" sz="2100" dirty="0" spc="-9" kern="0">
-                <a:solidFill>
-                  <a:srgbClr val="D8D3C4"/>
-                </a:solidFill>
-                <a:latin typeface="Be Vietnam Pro" pitchFamily="34" charset="0"/>
-                <a:ea typeface="Be Vietnam Pro" pitchFamily="34" charset="-122"/>
-                <a:cs typeface="Be Vietnam Pro" pitchFamily="34" charset="-120"/>
-              </a:rPr>
-              <a:t> số</a:t>
-            </a:r>
-            <a:r>
-              <a:rPr lang="en-US" sz="2100" dirty="0" spc="-2" kern="0">
-                <a:solidFill>
-                  <a:srgbClr val="D8D3C4"/>
-                </a:solidFill>
-                <a:latin typeface="Be Vietnam Pro" pitchFamily="34" charset="0"/>
-                <a:ea typeface="Be Vietnam Pro" pitchFamily="34" charset="-122"/>
-                <a:cs typeface="Be Vietnam Pro" pitchFamily="34" charset="-120"/>
-              </a:rPr>
-              <a:t> việc</a:t>
-            </a:r>
-            <a:r>
-              <a:rPr lang="en-US" sz="2100" dirty="0" spc="-8" kern="0">
-                <a:solidFill>
-                  <a:srgbClr val="D8D3C4"/>
-                </a:solidFill>
-                <a:latin typeface="Be Vietnam Pro" pitchFamily="34" charset="0"/>
-                <a:ea typeface="Be Vietnam Pro" pitchFamily="34" charset="-122"/>
-                <a:cs typeface="Be Vietnam Pro" pitchFamily="34" charset="-120"/>
-              </a:rPr>
-              <a:t> thay</a:t>
-            </a:r>
-            <a:r>
-              <a:rPr lang="en-US" sz="2100" dirty="0" spc="-4" kern="0">
-                <a:solidFill>
-                  <a:srgbClr val="D8D3C4"/>
-                </a:solidFill>
-                <a:latin typeface="Be Vietnam Pro" pitchFamily="34" charset="0"/>
-                <a:ea typeface="Be Vietnam Pro" pitchFamily="34" charset="-122"/>
-                <a:cs typeface="Be Vietnam Pro" pitchFamily="34" charset="-120"/>
-              </a:rPr>
-              <a:t> bạn.</a:t>
-            </a:r>
-            <a:endParaRPr lang="en-US" sz="2100" dirty="0"/>
+              <a:t> thay bạn.</a:t>
+            </a:r>
+            <a:endParaRPr lang="en-US" sz="2550" dirty="0"/>
           </a:p>
         </p:txBody>
       </p:sp>
       <p:sp>
         <p:nvSpPr>
-          <p:cNvPr id="28" name="Shape 26"/>
-          <p:cNvSpPr/>
-          <p:nvPr/>
-        </p:nvSpPr>
-        <p:spPr>
-          <a:xfrm>
-            <a:off x="6477000" y="5010150"/>
-            <a:ext cx="5334000" cy="2209800"/>
+          <p:cNvPr id="20" name="Shape 18"/>
+          <p:cNvSpPr/>
+          <p:nvPr/>
+        </p:nvSpPr>
+        <p:spPr>
+          <a:xfrm>
+            <a:off x="914400" y="4876800"/>
+            <a:ext cx="5381625" cy="2286000"/>
           </a:xfrm>
           <a:prstGeom prst="roundRect">
             <a:avLst>
-              <a:gd name="adj" fmla="val 11207"/>
+              <a:gd name="adj" fmla="val 9167"/>
             </a:avLst>
           </a:prstGeom>
           <a:solidFill>
@@ -5263,14 +5047,14 @@
       </p:sp>
       <p:sp>
         <p:nvSpPr>
-          <p:cNvPr id="29" name="Connector line-1792369924387-343610440"/>
-          <p:cNvSpPr/>
-          <p:nvPr/>
-        </p:nvSpPr>
-        <p:spPr>
-          <a:xfrm>
-            <a:off x="6724650" y="5257800"/>
-            <a:ext cx="4838700" cy="0"/>
+          <p:cNvPr id="21" name="Connector line-1792390670808-29120248"/>
+          <p:cNvSpPr/>
+          <p:nvPr/>
+        </p:nvSpPr>
+        <p:spPr>
+          <a:xfrm>
+            <a:off x="1162050" y="5124450"/>
+            <a:ext cx="4886325" cy="0"/>
           </a:xfrm>
           <a:prstGeom prst="line">
             <a:avLst/>
@@ -5288,13 +5072,13 @@
       </p:sp>
       <p:sp>
         <p:nvSpPr>
-          <p:cNvPr id="30" name="Shape 28"/>
-          <p:cNvSpPr/>
-          <p:nvPr/>
-        </p:nvSpPr>
-        <p:spPr>
-          <a:xfrm>
-            <a:off x="6648450" y="5181600"/>
+          <p:cNvPr id="22" name="Shape 20"/>
+          <p:cNvSpPr/>
+          <p:nvPr/>
+        </p:nvSpPr>
+        <p:spPr>
+          <a:xfrm>
+            <a:off x="1085850" y="5048250"/>
             <a:ext cx="152400" cy="152400"/>
           </a:xfrm>
           <a:prstGeom prst="ellipse">
@@ -5313,14 +5097,14 @@
       </p:sp>
       <p:sp>
         <p:nvSpPr>
-          <p:cNvPr id="31" name="Text 29"/>
-          <p:cNvSpPr/>
-          <p:nvPr/>
-        </p:nvSpPr>
-        <p:spPr>
-          <a:xfrm>
-            <a:off x="6724650" y="5448300"/>
-            <a:ext cx="4762500" cy="647700"/>
+          <p:cNvPr id="23" name="Text 21"/>
+          <p:cNvSpPr/>
+          <p:nvPr/>
+        </p:nvSpPr>
+        <p:spPr>
+          <a:xfrm>
+            <a:off x="1181100" y="5353050"/>
+            <a:ext cx="4848225" cy="1714500"/>
           </a:xfrm>
           <a:prstGeom prst="rect">
             <a:avLst/>
@@ -5329,106 +5113,74 @@
           <a:ln/>
         </p:spPr>
         <p:txBody>
-          <a:bodyPr wrap="square" lIns="0" tIns="0" rIns="0" bIns="0" rtlCol="0" anchor="t"/>
-          <a:lstStyle/>
-          <a:p>
-            <a:pPr algn="l" indent="0" marL="0">
-              <a:buNone/>
-            </a:pPr>
-            <a:r>
-              <a:rPr lang="en-US" sz="3900" dirty="0" spc="-3" kern="0">
-                <a:solidFill>
-                  <a:srgbClr val="3DD6A0"/>
-                </a:solidFill>
-                <a:latin typeface="Bricolage Grotesque ExtraBold" pitchFamily="34" charset="0"/>
-                <a:ea typeface="Bricolage Grotesque ExtraBold" pitchFamily="34" charset="-122"/>
-                <a:cs typeface="Bricolage Grotesque ExtraBold" pitchFamily="34" charset="-120"/>
-              </a:rPr>
-              <a:t>QR</a:t>
-            </a:r>
-            <a:endParaRPr lang="en-US" sz="3900" dirty="0"/>
-          </a:p>
-        </p:txBody>
-      </p:sp>
-      <p:sp>
-        <p:nvSpPr>
-          <p:cNvPr id="32" name="Text 30"/>
-          <p:cNvSpPr/>
-          <p:nvPr/>
-        </p:nvSpPr>
-        <p:spPr>
-          <a:xfrm>
-            <a:off x="6724650" y="6096000"/>
-            <a:ext cx="4857750" cy="285750"/>
-          </a:xfrm>
-          <a:prstGeom prst="rect">
-            <a:avLst/>
-          </a:prstGeom>
-          <a:noFill/>
-          <a:ln/>
-        </p:spPr>
-        <p:txBody>
-          <a:bodyPr wrap="square" lIns="0" tIns="0" rIns="0" bIns="0" rtlCol="0" anchor="t"/>
-          <a:lstStyle/>
-          <a:p>
-            <a:pPr algn="l" indent="0" marL="0">
-              <a:buNone/>
-            </a:pPr>
-            <a:r>
-              <a:rPr lang="en-US" sz="1650" dirty="0" spc="-2" kern="0">
-                <a:solidFill>
-                  <a:srgbClr val="9A98A0"/>
-                </a:solidFill>
-                <a:latin typeface="Be Vietnam Pro" pitchFamily="34" charset="0"/>
-                <a:ea typeface="Be Vietnam Pro" pitchFamily="34" charset="-122"/>
-                <a:cs typeface="Be Vietnam Pro" pitchFamily="34" charset="-120"/>
-              </a:rPr>
-              <a:t>Quick</a:t>
-            </a:r>
-            <a:r>
-              <a:rPr lang="en-US" sz="1650" dirty="0" spc="-12" kern="0">
-                <a:solidFill>
-                  <a:srgbClr val="9A98A0"/>
-                </a:solidFill>
-                <a:latin typeface="Be Vietnam Pro" pitchFamily="34" charset="0"/>
-                <a:ea typeface="Be Vietnam Pro" pitchFamily="34" charset="-122"/>
-                <a:cs typeface="Be Vietnam Pro" pitchFamily="34" charset="-120"/>
-              </a:rPr>
-              <a:t> Response</a:t>
-            </a:r>
-            <a:endParaRPr lang="en-US" sz="1650" dirty="0"/>
-          </a:p>
-        </p:txBody>
-      </p:sp>
-      <p:sp>
-        <p:nvSpPr>
-          <p:cNvPr id="33" name="Text 31"/>
-          <p:cNvSpPr/>
-          <p:nvPr/>
-        </p:nvSpPr>
-        <p:spPr>
-          <a:xfrm>
-            <a:off x="6724650" y="6400800"/>
-            <a:ext cx="4857750" cy="723900"/>
-          </a:xfrm>
-          <a:prstGeom prst="rect">
-            <a:avLst/>
-          </a:prstGeom>
-          <a:noFill/>
-          <a:ln/>
-        </p:spPr>
-        <p:txBody>
-          <a:bodyPr wrap="square" lIns="0" tIns="11335" rIns="0" bIns="-11335" rtlCol="0" anchor="t"/>
+          <a:bodyPr wrap="square" lIns="0" tIns="16192" rIns="0" bIns="-16192" rtlCol="0" anchor="t"/>
           <a:lstStyle/>
           <a:p>
             <a:pPr algn="l" indent="0" marL="0">
               <a:lnSpc>
-                <a:spcPts val="2730"/>
+                <a:spcPts val="2805"/>
+              </a:lnSpc>
+              <a:spcAft>
+                <a:spcPts val="600"/>
+              </a:spcAft>
+              <a:buNone/>
+            </a:pPr>
+            <a:r>
+              <a:rPr lang="en-US" sz="2550" dirty="0" spc="6" kern="0">
+                <a:solidFill>
+                  <a:srgbClr val="3DD6A0"/>
+                </a:solidFill>
+                <a:latin typeface="Bricolage Grotesque ExtraBold" pitchFamily="34" charset="0"/>
+                <a:ea typeface="Bricolage Grotesque ExtraBold" pitchFamily="34" charset="-122"/>
+                <a:cs typeface="Bricolage Grotesque ExtraBold" pitchFamily="34" charset="-120"/>
+              </a:rPr>
+              <a:t>QR</a:t>
+            </a:r>
+            <a:endParaRPr lang="en-US" sz="2550" dirty="0"/>
+          </a:p>
+          <a:p>
+            <a:pPr algn="l" indent="0" marL="0">
+              <a:lnSpc>
+                <a:spcPts val="2145"/>
+              </a:lnSpc>
+              <a:spcAft>
+                <a:spcPts val="600"/>
+              </a:spcAft>
+              <a:buNone/>
+            </a:pPr>
+            <a:r>
+              <a:rPr lang="en-US" sz="1650" dirty="0" spc="-2" kern="0">
+                <a:solidFill>
+                  <a:srgbClr val="9A98A0"/>
+                </a:solidFill>
+                <a:latin typeface="Be Vietnam Pro" pitchFamily="34" charset="0"/>
+                <a:ea typeface="Be Vietnam Pro" pitchFamily="34" charset="-122"/>
+                <a:cs typeface="Be Vietnam Pro" pitchFamily="34" charset="-120"/>
+              </a:rPr>
+              <a:t>Quick</a:t>
+            </a:r>
+            <a:r>
+              <a:rPr lang="en-US" sz="1650" dirty="0" spc="-12" kern="0">
+                <a:solidFill>
+                  <a:srgbClr val="9A98A0"/>
+                </a:solidFill>
+                <a:latin typeface="Be Vietnam Pro" pitchFamily="34" charset="0"/>
+                <a:ea typeface="Be Vietnam Pro" pitchFamily="34" charset="-122"/>
+                <a:cs typeface="Be Vietnam Pro" pitchFamily="34" charset="-120"/>
+              </a:rPr>
+              <a:t> Response</a:t>
+            </a:r>
+            <a:endParaRPr lang="en-US" sz="2550" dirty="0"/>
+          </a:p>
+          <a:p>
+            <a:pPr algn="l" indent="0" marL="0">
+              <a:lnSpc>
+                <a:spcPts val="2145"/>
               </a:lnSpc>
               <a:buNone/>
             </a:pPr>
             <a:r>
-              <a:rPr lang="en-US" sz="2100" dirty="0" spc="2" kern="0">
+              <a:rPr lang="en-US" sz="1650" dirty="0" spc="-1" kern="0">
                 <a:solidFill>
                   <a:srgbClr val="D8D3C4"/>
                 </a:solidFill>
@@ -5439,7 +5191,7 @@
               <a:t>Hình</a:t>
             </a:r>
             <a:r>
-              <a:rPr lang="en-US" sz="2100" dirty="0" spc="-5" kern="0">
+              <a:rPr lang="en-US" sz="1650" dirty="0" spc="2" kern="0">
                 <a:solidFill>
                   <a:srgbClr val="D8D3C4"/>
                 </a:solidFill>
@@ -5450,7 +5202,7 @@
               <a:t> ô</a:t>
             </a:r>
             <a:r>
-              <a:rPr lang="en-US" sz="2100" dirty="0" spc="10" kern="0">
+              <a:rPr lang="en-US" sz="1650" dirty="0" spc="10" kern="0">
                 <a:solidFill>
                   <a:srgbClr val="D8D3C4"/>
                 </a:solidFill>
@@ -5461,7 +5213,7 @@
               <a:t> đen</a:t>
             </a:r>
             <a:r>
-              <a:rPr lang="en-US" sz="2100" dirty="0" spc="-15" kern="0">
+              <a:rPr lang="en-US" sz="1650" dirty="0" spc="-9" kern="0">
                 <a:solidFill>
                   <a:srgbClr val="D8D3C4"/>
                 </a:solidFill>
@@ -5469,10 +5221,10 @@
                 <a:ea typeface="Be Vietnam Pro" pitchFamily="34" charset="-122"/>
                 <a:cs typeface="Be Vietnam Pro" pitchFamily="34" charset="-120"/>
               </a:rPr>
-              <a:t> trắng</a:t>
-            </a:r>
-            <a:r>
-              <a:rPr lang="en-US" sz="2100" dirty="0" spc="-3" kern="0">
+              <a:t> trắng,</a:t>
+            </a:r>
+            <a:r>
+              <a:rPr lang="en-US" sz="1650" dirty="0" spc="-10" kern="0">
                 <a:solidFill>
                   <a:srgbClr val="D8D3C4"/>
                 </a:solidFill>
@@ -5480,10 +5232,10 @@
                 <a:ea typeface="Be Vietnam Pro" pitchFamily="34" charset="-122"/>
                 <a:cs typeface="Be Vietnam Pro" pitchFamily="34" charset="-120"/>
               </a:rPr>
-              <a:t> mà</a:t>
-            </a:r>
-            <a:r>
-              <a:rPr lang="en-US" sz="2100" dirty="0" spc="-14" kern="0">
+              <a:t> camera</a:t>
+            </a:r>
+            <a:r>
+              <a:rPr lang="en-US" sz="1650" dirty="0" spc="8" kern="0">
                 <a:solidFill>
                   <a:srgbClr val="D8D3C4"/>
                 </a:solidFill>
@@ -5491,10 +5243,10 @@
                 <a:ea typeface="Be Vietnam Pro" pitchFamily="34" charset="-122"/>
                 <a:cs typeface="Be Vietnam Pro" pitchFamily="34" charset="-120"/>
               </a:rPr>
-              <a:t> camera</a:t>
-            </a:r>
-            <a:r>
-              <a:rPr lang="en-US" sz="2100" dirty="0" spc="6" kern="0">
+              <a:t> đọc</a:t>
+            </a:r>
+            <a:r>
+              <a:rPr lang="en-US" sz="1650" dirty="0" spc="1" kern="0">
                 <a:solidFill>
                   <a:srgbClr val="D8D3C4"/>
                 </a:solidFill>
@@ -5502,10 +5254,10 @@
                 <a:ea typeface="Be Vietnam Pro" pitchFamily="34" charset="-122"/>
                 <a:cs typeface="Be Vietnam Pro" pitchFamily="34" charset="-120"/>
               </a:rPr>
-              <a:t> đọc</a:t>
-            </a:r>
-            <a:r>
-              <a:rPr lang="en-US" sz="2100" dirty="0" spc="-2" kern="0">
+              <a:t> thành</a:t>
+            </a:r>
+            <a:r>
+              <a:rPr lang="en-US" sz="1650" dirty="0" spc="0" kern="0">
                 <a:solidFill>
                   <a:srgbClr val="D8D3C4"/>
                 </a:solidFill>
@@ -5513,48 +5265,26 @@
                 <a:ea typeface="Be Vietnam Pro" pitchFamily="34" charset="-122"/>
                 <a:cs typeface="Be Vietnam Pro" pitchFamily="34" charset="-120"/>
               </a:rPr>
-              <a:t> thành</a:t>
-            </a:r>
-            <a:r>
-              <a:rPr lang="en-US" sz="2100" dirty="0" spc="-1" kern="0">
-                <a:solidFill>
-                  <a:srgbClr val="D8D3C4"/>
-                </a:solidFill>
-                <a:latin typeface="Be Vietnam Pro" pitchFamily="34" charset="0"/>
-                <a:ea typeface="Be Vietnam Pro" pitchFamily="34" charset="-122"/>
-                <a:cs typeface="Be Vietnam Pro" pitchFamily="34" charset="-120"/>
-              </a:rPr>
-              <a:t> chuỗi</a:t>
-            </a:r>
-            <a:r>
-              <a:rPr lang="en-US" sz="2100" dirty="0" spc="0" kern="0">
-                <a:solidFill>
-                  <a:srgbClr val="D8D3C4"/>
-                </a:solidFill>
-                <a:latin typeface="Be Vietnam Pro" pitchFamily="34" charset="0"/>
-                <a:ea typeface="Be Vietnam Pro" pitchFamily="34" charset="-122"/>
-                <a:cs typeface="Be Vietnam Pro" pitchFamily="34" charset="-120"/>
-              </a:rPr>
               <a:t> chữ.</a:t>
             </a:r>
-            <a:endParaRPr lang="en-US" sz="2100" dirty="0"/>
+            <a:endParaRPr lang="en-US" sz="2550" dirty="0"/>
           </a:p>
         </p:txBody>
       </p:sp>
       <p:sp>
         <p:nvSpPr>
-          <p:cNvPr id="34" name="Shape 32"/>
-          <p:cNvSpPr/>
-          <p:nvPr/>
-        </p:nvSpPr>
-        <p:spPr>
-          <a:xfrm>
-            <a:off x="12039600" y="5010150"/>
-            <a:ext cx="5334000" cy="2209800"/>
+          <p:cNvPr id="24" name="Shape 22"/>
+          <p:cNvSpPr/>
+          <p:nvPr/>
+        </p:nvSpPr>
+        <p:spPr>
+          <a:xfrm>
+            <a:off x="6448425" y="4876800"/>
+            <a:ext cx="5391150" cy="2286000"/>
           </a:xfrm>
           <a:prstGeom prst="roundRect">
             <a:avLst>
-              <a:gd name="adj" fmla="val 11207"/>
+              <a:gd name="adj" fmla="val 9167"/>
             </a:avLst>
           </a:prstGeom>
           <a:solidFill>
@@ -5565,14 +5295,14 @@
       </p:sp>
       <p:sp>
         <p:nvSpPr>
-          <p:cNvPr id="35" name="Connector line-1792369924395-408896262"/>
-          <p:cNvSpPr/>
-          <p:nvPr/>
-        </p:nvSpPr>
-        <p:spPr>
-          <a:xfrm>
-            <a:off x="12287250" y="5257800"/>
-            <a:ext cx="4838700" cy="0"/>
+          <p:cNvPr id="25" name="Connector line-1792390670811-112875577"/>
+          <p:cNvSpPr/>
+          <p:nvPr/>
+        </p:nvSpPr>
+        <p:spPr>
+          <a:xfrm>
+            <a:off x="6696075" y="5124450"/>
+            <a:ext cx="4895850" cy="0"/>
           </a:xfrm>
           <a:prstGeom prst="line">
             <a:avLst/>
@@ -5590,13 +5320,13 @@
       </p:sp>
       <p:sp>
         <p:nvSpPr>
-          <p:cNvPr id="36" name="Shape 34"/>
-          <p:cNvSpPr/>
-          <p:nvPr/>
-        </p:nvSpPr>
-        <p:spPr>
-          <a:xfrm>
-            <a:off x="12211050" y="5181600"/>
+          <p:cNvPr id="26" name="Shape 24"/>
+          <p:cNvSpPr/>
+          <p:nvPr/>
+        </p:nvSpPr>
+        <p:spPr>
+          <a:xfrm>
+            <a:off x="6619875" y="5048250"/>
             <a:ext cx="152400" cy="152400"/>
           </a:xfrm>
           <a:prstGeom prst="ellipse">
@@ -5615,14 +5345,471 @@
       </p:sp>
       <p:sp>
         <p:nvSpPr>
-          <p:cNvPr id="37" name="Text 35"/>
-          <p:cNvSpPr/>
-          <p:nvPr/>
-        </p:nvSpPr>
-        <p:spPr>
-          <a:xfrm>
-            <a:off x="12287250" y="5448300"/>
-            <a:ext cx="4762500" cy="647700"/>
+          <p:cNvPr id="27" name="Text 25"/>
+          <p:cNvSpPr/>
+          <p:nvPr/>
+        </p:nvSpPr>
+        <p:spPr>
+          <a:xfrm>
+            <a:off x="6715125" y="5353050"/>
+            <a:ext cx="4857750" cy="1714500"/>
+          </a:xfrm>
+          <a:prstGeom prst="rect">
+            <a:avLst/>
+          </a:prstGeom>
+          <a:noFill/>
+          <a:ln/>
+        </p:spPr>
+        <p:txBody>
+          <a:bodyPr wrap="square" lIns="0" tIns="16192" rIns="0" bIns="-16192" rtlCol="0" anchor="t"/>
+          <a:lstStyle/>
+          <a:p>
+            <a:pPr algn="l" indent="0" marL="0">
+              <a:lnSpc>
+                <a:spcPts val="2805"/>
+              </a:lnSpc>
+              <a:spcAft>
+                <a:spcPts val="600"/>
+              </a:spcAft>
+              <a:buNone/>
+            </a:pPr>
+            <a:r>
+              <a:rPr lang="en-US" sz="2550" dirty="0" spc="-62" kern="0">
+                <a:solidFill>
+                  <a:srgbClr val="D8D3C4"/>
+                </a:solidFill>
+                <a:latin typeface="Bricolage Grotesque ExtraBold" pitchFamily="34" charset="0"/>
+                <a:ea typeface="Bricolage Grotesque ExtraBold" pitchFamily="34" charset="-122"/>
+                <a:cs typeface="Bricolage Grotesque ExtraBold" pitchFamily="34" charset="-120"/>
+              </a:rPr>
+              <a:t>OWASP</a:t>
+            </a:r>
+            <a:endParaRPr lang="en-US" sz="2550" dirty="0"/>
+          </a:p>
+          <a:p>
+            <a:pPr algn="l" indent="0" marL="0">
+              <a:lnSpc>
+                <a:spcPts val="2145"/>
+              </a:lnSpc>
+              <a:spcAft>
+                <a:spcPts val="600"/>
+              </a:spcAft>
+              <a:buNone/>
+            </a:pPr>
+            <a:r>
+              <a:rPr lang="en-US" sz="1650" dirty="0" spc="-3" kern="0">
+                <a:solidFill>
+                  <a:srgbClr val="9A98A0"/>
+                </a:solidFill>
+                <a:latin typeface="Be Vietnam Pro" pitchFamily="34" charset="0"/>
+                <a:ea typeface="Be Vietnam Pro" pitchFamily="34" charset="-122"/>
+                <a:cs typeface="Be Vietnam Pro" pitchFamily="34" charset="-120"/>
+              </a:rPr>
+              <a:t>Open</a:t>
+            </a:r>
+            <a:r>
+              <a:rPr lang="en-US" sz="1650" dirty="0" spc="-8" kern="0">
+                <a:solidFill>
+                  <a:srgbClr val="9A98A0"/>
+                </a:solidFill>
+                <a:latin typeface="Be Vietnam Pro" pitchFamily="34" charset="0"/>
+                <a:ea typeface="Be Vietnam Pro" pitchFamily="34" charset="-122"/>
+                <a:cs typeface="Be Vietnam Pro" pitchFamily="34" charset="-120"/>
+              </a:rPr>
+              <a:t> Worldwide</a:t>
+            </a:r>
+            <a:r>
+              <a:rPr lang="en-US" sz="1650" dirty="0" spc="-4" kern="0">
+                <a:solidFill>
+                  <a:srgbClr val="9A98A0"/>
+                </a:solidFill>
+                <a:latin typeface="Be Vietnam Pro" pitchFamily="34" charset="0"/>
+                <a:ea typeface="Be Vietnam Pro" pitchFamily="34" charset="-122"/>
+                <a:cs typeface="Be Vietnam Pro" pitchFamily="34" charset="-120"/>
+              </a:rPr>
+              <a:t> Application</a:t>
+            </a:r>
+            <a:r>
+              <a:rPr lang="en-US" sz="1650" dirty="0" spc="1" kern="0">
+                <a:solidFill>
+                  <a:srgbClr val="9A98A0"/>
+                </a:solidFill>
+                <a:latin typeface="Be Vietnam Pro" pitchFamily="34" charset="0"/>
+                <a:ea typeface="Be Vietnam Pro" pitchFamily="34" charset="-122"/>
+                <a:cs typeface="Be Vietnam Pro" pitchFamily="34" charset="-120"/>
+              </a:rPr>
+              <a:t> Security</a:t>
+            </a:r>
+            <a:r>
+              <a:rPr lang="en-US" sz="1650" dirty="0" spc="-16" kern="0">
+                <a:solidFill>
+                  <a:srgbClr val="9A98A0"/>
+                </a:solidFill>
+                <a:latin typeface="Be Vietnam Pro" pitchFamily="34" charset="0"/>
+                <a:ea typeface="Be Vietnam Pro" pitchFamily="34" charset="-122"/>
+                <a:cs typeface="Be Vietnam Pro" pitchFamily="34" charset="-120"/>
+              </a:rPr>
+              <a:t> Project</a:t>
+            </a:r>
+            <a:endParaRPr lang="en-US" sz="2550" dirty="0"/>
+          </a:p>
+          <a:p>
+            <a:pPr algn="l" indent="0" marL="0">
+              <a:lnSpc>
+                <a:spcPts val="2145"/>
+              </a:lnSpc>
+              <a:buNone/>
+            </a:pPr>
+            <a:r>
+              <a:rPr lang="en-US" sz="1650" dirty="0" spc="0" kern="0">
+                <a:solidFill>
+                  <a:srgbClr val="D8D3C4"/>
+                </a:solidFill>
+                <a:latin typeface="Be Vietnam Pro" pitchFamily="34" charset="0"/>
+                <a:ea typeface="Be Vietnam Pro" pitchFamily="34" charset="-122"/>
+                <a:cs typeface="Be Vietnam Pro" pitchFamily="34" charset="-120"/>
+              </a:rPr>
+              <a:t>Cộng</a:t>
+            </a:r>
+            <a:r>
+              <a:rPr lang="en-US" sz="1650" dirty="0" spc="7" kern="0">
+                <a:solidFill>
+                  <a:srgbClr val="D8D3C4"/>
+                </a:solidFill>
+                <a:latin typeface="Be Vietnam Pro" pitchFamily="34" charset="0"/>
+                <a:ea typeface="Be Vietnam Pro" pitchFamily="34" charset="-122"/>
+                <a:cs typeface="Be Vietnam Pro" pitchFamily="34" charset="-120"/>
+              </a:rPr>
+              <a:t> đồng</a:t>
+            </a:r>
+            <a:r>
+              <a:rPr lang="en-US" sz="1650" dirty="0" spc="-8" kern="0">
+                <a:solidFill>
+                  <a:srgbClr val="D8D3C4"/>
+                </a:solidFill>
+                <a:latin typeface="Be Vietnam Pro" pitchFamily="34" charset="0"/>
+                <a:ea typeface="Be Vietnam Pro" pitchFamily="34" charset="-122"/>
+                <a:cs typeface="Be Vietnam Pro" pitchFamily="34" charset="-120"/>
+              </a:rPr>
+              <a:t> chuyên về</a:t>
+            </a:r>
+            <a:r>
+              <a:rPr lang="en-US" sz="1650" dirty="0" spc="-1" kern="0">
+                <a:solidFill>
+                  <a:srgbClr val="D8D3C4"/>
+                </a:solidFill>
+                <a:latin typeface="Be Vietnam Pro" pitchFamily="34" charset="0"/>
+                <a:ea typeface="Be Vietnam Pro" pitchFamily="34" charset="-122"/>
+                <a:cs typeface="Be Vietnam Pro" pitchFamily="34" charset="-120"/>
+              </a:rPr>
+              <a:t> bảo</a:t>
+            </a:r>
+            <a:r>
+              <a:rPr lang="en-US" sz="1650" dirty="0" spc="-6" kern="0">
+                <a:solidFill>
+                  <a:srgbClr val="D8D3C4"/>
+                </a:solidFill>
+                <a:latin typeface="Be Vietnam Pro" pitchFamily="34" charset="0"/>
+                <a:ea typeface="Be Vietnam Pro" pitchFamily="34" charset="-122"/>
+                <a:cs typeface="Be Vietnam Pro" pitchFamily="34" charset="-120"/>
+              </a:rPr>
+              <a:t> mật</a:t>
+            </a:r>
+            <a:r>
+              <a:rPr lang="en-US" sz="1650" dirty="0" spc="16" kern="0">
+                <a:solidFill>
+                  <a:srgbClr val="D8D3C4"/>
+                </a:solidFill>
+                <a:latin typeface="Be Vietnam Pro" pitchFamily="34" charset="0"/>
+                <a:ea typeface="Be Vietnam Pro" pitchFamily="34" charset="-122"/>
+                <a:cs typeface="Be Vietnam Pro" pitchFamily="34" charset="-120"/>
+              </a:rPr>
+              <a:t> ứng</a:t>
+            </a:r>
+            <a:r>
+              <a:rPr lang="en-US" sz="1650" dirty="0" spc="0" kern="0">
+                <a:solidFill>
+                  <a:srgbClr val="D8D3C4"/>
+                </a:solidFill>
+                <a:latin typeface="Be Vietnam Pro" pitchFamily="34" charset="0"/>
+                <a:ea typeface="Be Vietnam Pro" pitchFamily="34" charset="-122"/>
+                <a:cs typeface="Be Vietnam Pro" pitchFamily="34" charset="-120"/>
+              </a:rPr>
+              <a:t> dụng.</a:t>
+            </a:r>
+            <a:endParaRPr lang="en-US" sz="2550" dirty="0"/>
+          </a:p>
+        </p:txBody>
+      </p:sp>
+      <p:sp>
+        <p:nvSpPr>
+          <p:cNvPr id="28" name="Shape 26"/>
+          <p:cNvSpPr/>
+          <p:nvPr/>
+        </p:nvSpPr>
+        <p:spPr>
+          <a:xfrm>
+            <a:off x="11991975" y="4876800"/>
+            <a:ext cx="5381625" cy="2286000"/>
+          </a:xfrm>
+          <a:prstGeom prst="roundRect">
+            <a:avLst>
+              <a:gd name="adj" fmla="val 9167"/>
+            </a:avLst>
+          </a:prstGeom>
+          <a:solidFill>
+            <a:srgbClr val="1E212B"/>
+          </a:solidFill>
+          <a:ln/>
+        </p:spPr>
+      </p:sp>
+      <p:sp>
+        <p:nvSpPr>
+          <p:cNvPr id="29" name="Connector line-1792390670815-29232641"/>
+          <p:cNvSpPr/>
+          <p:nvPr/>
+        </p:nvSpPr>
+        <p:spPr>
+          <a:xfrm>
+            <a:off x="12239625" y="5124450"/>
+            <a:ext cx="4886325" cy="0"/>
+          </a:xfrm>
+          <a:prstGeom prst="line">
+            <a:avLst/>
+          </a:prstGeom>
+          <a:noFill/>
+          <a:ln w="28575">
+            <a:solidFill>
+              <a:srgbClr val="FF6A4D"/>
+            </a:solidFill>
+            <a:prstDash val="solid"/>
+            <a:headEnd type="none"/>
+            <a:tailEnd type="none"/>
+          </a:ln>
+        </p:spPr>
+      </p:sp>
+      <p:sp>
+        <p:nvSpPr>
+          <p:cNvPr id="30" name="Shape 28"/>
+          <p:cNvSpPr/>
+          <p:nvPr/>
+        </p:nvSpPr>
+        <p:spPr>
+          <a:xfrm>
+            <a:off x="12163425" y="5048250"/>
+            <a:ext cx="152400" cy="152400"/>
+          </a:xfrm>
+          <a:prstGeom prst="ellipse">
+            <a:avLst/>
+          </a:prstGeom>
+          <a:solidFill>
+            <a:srgbClr val="1E212B"/>
+          </a:solidFill>
+          <a:ln w="28575">
+            <a:solidFill>
+              <a:srgbClr val="FF6A4D"/>
+            </a:solidFill>
+            <a:prstDash val="solid"/>
+          </a:ln>
+        </p:spPr>
+      </p:sp>
+      <p:sp>
+        <p:nvSpPr>
+          <p:cNvPr id="31" name="Text 29"/>
+          <p:cNvSpPr/>
+          <p:nvPr/>
+        </p:nvSpPr>
+        <p:spPr>
+          <a:xfrm>
+            <a:off x="12258675" y="5353050"/>
+            <a:ext cx="4848225" cy="1714500"/>
+          </a:xfrm>
+          <a:prstGeom prst="rect">
+            <a:avLst/>
+          </a:prstGeom>
+          <a:noFill/>
+          <a:ln/>
+        </p:spPr>
+        <p:txBody>
+          <a:bodyPr wrap="square" lIns="0" tIns="16192" rIns="0" bIns="-16192" rtlCol="0" anchor="t"/>
+          <a:lstStyle/>
+          <a:p>
+            <a:pPr algn="l" indent="0" marL="0">
+              <a:lnSpc>
+                <a:spcPts val="2805"/>
+              </a:lnSpc>
+              <a:spcAft>
+                <a:spcPts val="600"/>
+              </a:spcAft>
+              <a:buNone/>
+            </a:pPr>
+            <a:r>
+              <a:rPr lang="en-US" sz="2550" dirty="0" spc="6" kern="0">
+                <a:solidFill>
+                  <a:srgbClr val="FF6A4D"/>
+                </a:solidFill>
+                <a:latin typeface="Bricolage Grotesque ExtraBold" pitchFamily="34" charset="0"/>
+                <a:ea typeface="Bricolage Grotesque ExtraBold" pitchFamily="34" charset="-122"/>
+                <a:cs typeface="Bricolage Grotesque ExtraBold" pitchFamily="34" charset="-120"/>
+              </a:rPr>
+              <a:t>CSRF</a:t>
+            </a:r>
+            <a:endParaRPr lang="en-US" sz="2550" dirty="0"/>
+          </a:p>
+          <a:p>
+            <a:pPr algn="l" indent="0" marL="0">
+              <a:lnSpc>
+                <a:spcPts val="2145"/>
+              </a:lnSpc>
+              <a:spcAft>
+                <a:spcPts val="600"/>
+              </a:spcAft>
+              <a:buNone/>
+            </a:pPr>
+            <a:r>
+              <a:rPr lang="en-US" sz="1650" dirty="0" spc="-9" kern="0">
+                <a:solidFill>
+                  <a:srgbClr val="9A98A0"/>
+                </a:solidFill>
+                <a:latin typeface="Be Vietnam Pro" pitchFamily="34" charset="0"/>
+                <a:ea typeface="Be Vietnam Pro" pitchFamily="34" charset="-122"/>
+                <a:cs typeface="Be Vietnam Pro" pitchFamily="34" charset="-120"/>
+              </a:rPr>
+              <a:t>Cross-Site</a:t>
+            </a:r>
+            <a:r>
+              <a:rPr lang="en-US" sz="1650" dirty="0" spc="-12" kern="0">
+                <a:solidFill>
+                  <a:srgbClr val="9A98A0"/>
+                </a:solidFill>
+                <a:latin typeface="Be Vietnam Pro" pitchFamily="34" charset="0"/>
+                <a:ea typeface="Be Vietnam Pro" pitchFamily="34" charset="-122"/>
+                <a:cs typeface="Be Vietnam Pro" pitchFamily="34" charset="-120"/>
+              </a:rPr>
+              <a:t> Request</a:t>
+            </a:r>
+            <a:r>
+              <a:rPr lang="en-US" sz="1650" dirty="0" spc="-25" kern="0">
+                <a:solidFill>
+                  <a:srgbClr val="9A98A0"/>
+                </a:solidFill>
+                <a:latin typeface="Be Vietnam Pro" pitchFamily="34" charset="0"/>
+                <a:ea typeface="Be Vietnam Pro" pitchFamily="34" charset="-122"/>
+                <a:cs typeface="Be Vietnam Pro" pitchFamily="34" charset="-120"/>
+              </a:rPr>
+              <a:t> Forgery</a:t>
+            </a:r>
+            <a:endParaRPr lang="en-US" sz="2550" dirty="0"/>
+          </a:p>
+          <a:p>
+            <a:pPr algn="l" indent="0" marL="0">
+              <a:lnSpc>
+                <a:spcPts val="2145"/>
+              </a:lnSpc>
+              <a:buNone/>
+            </a:pPr>
+            <a:r>
+              <a:rPr lang="en-US" sz="1650" dirty="0" spc="-18" kern="0">
+                <a:solidFill>
+                  <a:srgbClr val="D8D3C4"/>
+                </a:solidFill>
+                <a:latin typeface="Be Vietnam Pro" pitchFamily="34" charset="0"/>
+                <a:ea typeface="Be Vietnam Pro" pitchFamily="34" charset="-122"/>
+                <a:cs typeface="Be Vietnam Pro" pitchFamily="34" charset="-120"/>
+              </a:rPr>
+              <a:t>Trình</a:t>
+            </a:r>
+            <a:r>
+              <a:rPr lang="en-US" sz="1650" dirty="0" spc="-10" kern="0">
+                <a:solidFill>
+                  <a:srgbClr val="D8D3C4"/>
+                </a:solidFill>
+                <a:latin typeface="Be Vietnam Pro" pitchFamily="34" charset="0"/>
+                <a:ea typeface="Be Vietnam Pro" pitchFamily="34" charset="-122"/>
+                <a:cs typeface="Be Vietnam Pro" pitchFamily="34" charset="-120"/>
+              </a:rPr>
+              <a:t> duyệt</a:t>
+            </a:r>
+            <a:r>
+              <a:rPr lang="en-US" sz="1650" dirty="0" spc="27" kern="0">
+                <a:solidFill>
+                  <a:srgbClr val="D8D3C4"/>
+                </a:solidFill>
+                <a:latin typeface="Be Vietnam Pro" pitchFamily="34" charset="0"/>
+                <a:ea typeface="Be Vietnam Pro" pitchFamily="34" charset="-122"/>
+                <a:cs typeface="Be Vietnam Pro" pitchFamily="34" charset="-120"/>
+              </a:rPr>
+              <a:t> gửi</a:t>
+            </a:r>
+            <a:r>
+              <a:rPr lang="en-US" sz="1650" dirty="0" spc="-13" kern="0">
+                <a:solidFill>
+                  <a:srgbClr val="D8D3C4"/>
+                </a:solidFill>
+                <a:latin typeface="Be Vietnam Pro" pitchFamily="34" charset="0"/>
+                <a:ea typeface="Be Vietnam Pro" pitchFamily="34" charset="-122"/>
+                <a:cs typeface="Be Vietnam Pro" pitchFamily="34" charset="-120"/>
+              </a:rPr>
+              <a:t> yêu</a:t>
+            </a:r>
+            <a:r>
+              <a:rPr lang="en-US" sz="1650" dirty="0" spc="1" kern="0">
+                <a:solidFill>
+                  <a:srgbClr val="D8D3C4"/>
+                </a:solidFill>
+                <a:latin typeface="Be Vietnam Pro" pitchFamily="34" charset="0"/>
+                <a:ea typeface="Be Vietnam Pro" pitchFamily="34" charset="-122"/>
+                <a:cs typeface="Be Vietnam Pro" pitchFamily="34" charset="-120"/>
+              </a:rPr>
+              <a:t> cầu</a:t>
+            </a:r>
+            <a:r>
+              <a:rPr lang="en-US" sz="1650" dirty="0" spc="-8" kern="0">
+                <a:solidFill>
+                  <a:srgbClr val="D8D3C4"/>
+                </a:solidFill>
+                <a:latin typeface="Be Vietnam Pro" pitchFamily="34" charset="0"/>
+                <a:ea typeface="Be Vietnam Pro" pitchFamily="34" charset="-122"/>
+                <a:cs typeface="Be Vietnam Pro" pitchFamily="34" charset="-120"/>
+              </a:rPr>
+              <a:t> ngoài</a:t>
+            </a:r>
+            <a:r>
+              <a:rPr lang="en-US" sz="1650" dirty="0" spc="2" kern="0">
+                <a:solidFill>
+                  <a:srgbClr val="D8D3C4"/>
+                </a:solidFill>
+                <a:latin typeface="Be Vietnam Pro" pitchFamily="34" charset="0"/>
+                <a:ea typeface="Be Vietnam Pro" pitchFamily="34" charset="-122"/>
+                <a:cs typeface="Be Vietnam Pro" pitchFamily="34" charset="-120"/>
+              </a:rPr>
+              <a:t> ý</a:t>
+            </a:r>
+            <a:r>
+              <a:rPr lang="en-US" sz="1650" dirty="0" spc="-1" kern="0">
+                <a:solidFill>
+                  <a:srgbClr val="D8D3C4"/>
+                </a:solidFill>
+                <a:latin typeface="Be Vietnam Pro" pitchFamily="34" charset="0"/>
+                <a:ea typeface="Be Vietnam Pro" pitchFamily="34" charset="-122"/>
+                <a:cs typeface="Be Vietnam Pro" pitchFamily="34" charset="-120"/>
+              </a:rPr>
+              <a:t> muốn.</a:t>
+            </a:r>
+            <a:endParaRPr lang="en-US" sz="2550" dirty="0"/>
+          </a:p>
+        </p:txBody>
+      </p:sp>
+      <p:sp>
+        <p:nvSpPr>
+          <p:cNvPr id="32" name="Text 30"/>
+          <p:cNvSpPr/>
+          <p:nvPr/>
+        </p:nvSpPr>
+        <p:spPr>
+          <a:xfrm>
+            <a:off x="914400" y="7772400"/>
+            <a:ext cx="7620000" cy="323850"/>
           </a:xfrm>
           <a:prstGeom prst="rect">
             <a:avLst/>
@@ -5638,30 +5825,41 @@
               <a:buNone/>
             </a:pPr>
             <a:r>
-              <a:rPr lang="en-US" sz="3900" dirty="0" spc="-95" kern="0">
-                <a:solidFill>
-                  <a:srgbClr val="D8D3C4"/>
-                </a:solidFill>
-                <a:latin typeface="Bricolage Grotesque ExtraBold" pitchFamily="34" charset="0"/>
-                <a:ea typeface="Bricolage Grotesque ExtraBold" pitchFamily="34" charset="-122"/>
-                <a:cs typeface="Bricolage Grotesque ExtraBold" pitchFamily="34" charset="-120"/>
-              </a:rPr>
-              <a:t>OWASP</a:t>
-            </a:r>
-            <a:endParaRPr lang="en-US" sz="3900" dirty="0"/>
+              <a:rPr lang="en-US" sz="1800" b="1" spc="225" kern="0" dirty="0">
+                <a:solidFill>
+                  <a:srgbClr val="FF6A4D"/>
+                </a:solidFill>
+                <a:latin typeface="Be Vietnam Pro" pitchFamily="34" charset="0"/>
+                <a:ea typeface="Be Vietnam Pro" pitchFamily="34" charset="-122"/>
+                <a:cs typeface="Be Vietnam Pro" pitchFamily="34" charset="-120"/>
+              </a:rPr>
+              <a:t>NGUỒN ĐỐI</a:t>
+            </a:r>
+            <a:r>
+              <a:rPr lang="en-US" sz="1800" b="1" spc="227" kern="0" dirty="0">
+                <a:solidFill>
+                  <a:srgbClr val="FF6A4D"/>
+                </a:solidFill>
+                <a:latin typeface="Be Vietnam Pro" pitchFamily="34" charset="0"/>
+                <a:ea typeface="Be Vietnam Pro" pitchFamily="34" charset="-122"/>
+                <a:cs typeface="Be Vietnam Pro" pitchFamily="34" charset="-120"/>
+              </a:rPr>
+              <a:t> CHIẾU</a:t>
+            </a:r>
+            <a:endParaRPr lang="en-US" sz="1800" dirty="0"/>
           </a:p>
         </p:txBody>
       </p:sp>
       <p:sp>
         <p:nvSpPr>
-          <p:cNvPr id="38" name="Text 36"/>
-          <p:cNvSpPr/>
-          <p:nvPr/>
-        </p:nvSpPr>
-        <p:spPr>
-          <a:xfrm>
-            <a:off x="12287250" y="6096000"/>
-            <a:ext cx="4953000" cy="285750"/>
+          <p:cNvPr id="33" name="Text 31"/>
+          <p:cNvSpPr/>
+          <p:nvPr/>
+        </p:nvSpPr>
+        <p:spPr>
+          <a:xfrm>
+            <a:off x="914400" y="8172450"/>
+            <a:ext cx="16459200" cy="361950"/>
           </a:xfrm>
           <a:prstGeom prst="rect">
             <a:avLst/>
@@ -5677,215 +5875,140 @@
               <a:buNone/>
             </a:pPr>
             <a:r>
-              <a:rPr lang="en-US" sz="1650" dirty="0" spc="-3" kern="0">
-                <a:solidFill>
-                  <a:srgbClr val="9A98A0"/>
-                </a:solidFill>
-                <a:latin typeface="Be Vietnam Pro" pitchFamily="34" charset="0"/>
-                <a:ea typeface="Be Vietnam Pro" pitchFamily="34" charset="-122"/>
-                <a:cs typeface="Be Vietnam Pro" pitchFamily="34" charset="-120"/>
-              </a:rPr>
-              <a:t>Open</a:t>
-            </a:r>
-            <a:r>
-              <a:rPr lang="en-US" sz="1650" dirty="0" spc="-8" kern="0">
-                <a:solidFill>
-                  <a:srgbClr val="9A98A0"/>
-                </a:solidFill>
-                <a:latin typeface="Be Vietnam Pro" pitchFamily="34" charset="0"/>
-                <a:ea typeface="Be Vietnam Pro" pitchFamily="34" charset="-122"/>
-                <a:cs typeface="Be Vietnam Pro" pitchFamily="34" charset="-120"/>
-              </a:rPr>
-              <a:t> Worldwide</a:t>
-            </a:r>
-            <a:r>
-              <a:rPr lang="en-US" sz="1650" dirty="0" spc="-4" kern="0">
-                <a:solidFill>
-                  <a:srgbClr val="9A98A0"/>
-                </a:solidFill>
-                <a:latin typeface="Be Vietnam Pro" pitchFamily="34" charset="0"/>
-                <a:ea typeface="Be Vietnam Pro" pitchFamily="34" charset="-122"/>
-                <a:cs typeface="Be Vietnam Pro" pitchFamily="34" charset="-120"/>
-              </a:rPr>
-              <a:t> Application</a:t>
-            </a:r>
-            <a:r>
-              <a:rPr lang="en-US" sz="1650" dirty="0" spc="1" kern="0">
-                <a:solidFill>
-                  <a:srgbClr val="9A98A0"/>
-                </a:solidFill>
-                <a:latin typeface="Be Vietnam Pro" pitchFamily="34" charset="0"/>
-                <a:ea typeface="Be Vietnam Pro" pitchFamily="34" charset="-122"/>
-                <a:cs typeface="Be Vietnam Pro" pitchFamily="34" charset="-120"/>
-              </a:rPr>
-              <a:t> Security</a:t>
-            </a:r>
-            <a:r>
-              <a:rPr lang="en-US" sz="1650" dirty="0" spc="-16" kern="0">
-                <a:solidFill>
-                  <a:srgbClr val="9A98A0"/>
-                </a:solidFill>
-                <a:latin typeface="Be Vietnam Pro" pitchFamily="34" charset="0"/>
-                <a:ea typeface="Be Vietnam Pro" pitchFamily="34" charset="-122"/>
-                <a:cs typeface="Be Vietnam Pro" pitchFamily="34" charset="-120"/>
-              </a:rPr>
-              <a:t> Project</a:t>
-            </a:r>
-            <a:endParaRPr lang="en-US" sz="1650" dirty="0"/>
+              <a:rPr lang="en-US" sz="1950" dirty="0" spc="-3" kern="0">
+                <a:solidFill>
+                  <a:srgbClr val="F3EEE3"/>
+                </a:solidFill>
+                <a:latin typeface="Be Vietnam Pro" pitchFamily="34" charset="0"/>
+                <a:ea typeface="Be Vietnam Pro" pitchFamily="34" charset="-122"/>
+                <a:cs typeface="Be Vietnam Pro" pitchFamily="34" charset="-120"/>
+              </a:rPr>
+              <a:t>ByteByteGo</a:t>
+            </a:r>
+            <a:r>
+              <a:rPr lang="en-US" sz="1950" dirty="0" spc="-1" kern="0">
+                <a:solidFill>
+                  <a:srgbClr val="F3EEE3"/>
+                </a:solidFill>
+                <a:latin typeface="Be Vietnam Pro" pitchFamily="34" charset="0"/>
+                <a:ea typeface="Be Vietnam Pro" pitchFamily="34" charset="-122"/>
+                <a:cs typeface="Be Vietnam Pro" pitchFamily="34" charset="-120"/>
+              </a:rPr>
+              <a:t> ·</a:t>
+            </a:r>
+            <a:r>
+              <a:rPr lang="en-US" sz="1950" dirty="0" spc="-43" kern="0">
+                <a:solidFill>
+                  <a:srgbClr val="F3EEE3"/>
+                </a:solidFill>
+                <a:latin typeface="Be Vietnam Pro" pitchFamily="34" charset="0"/>
+                <a:ea typeface="Be Vietnam Pro" pitchFamily="34" charset="-122"/>
+                <a:cs typeface="Be Vietnam Pro" pitchFamily="34" charset="-120"/>
+              </a:rPr>
+              <a:t> OWASP</a:t>
+            </a:r>
+            <a:r>
+              <a:rPr lang="en-US" sz="1950" dirty="0" spc="1" kern="0">
+                <a:solidFill>
+                  <a:srgbClr val="F3EEE3"/>
+                </a:solidFill>
+                <a:latin typeface="Be Vietnam Pro" pitchFamily="34" charset="0"/>
+                <a:ea typeface="Be Vietnam Pro" pitchFamily="34" charset="-122"/>
+                <a:cs typeface="Be Vietnam Pro" pitchFamily="34" charset="-120"/>
+              </a:rPr>
+              <a:t> (QRLJacking,</a:t>
+            </a:r>
+            <a:r>
+              <a:rPr lang="en-US" sz="1950" dirty="0" spc="-7" kern="0">
+                <a:solidFill>
+                  <a:srgbClr val="F3EEE3"/>
+                </a:solidFill>
+                <a:latin typeface="Be Vietnam Pro" pitchFamily="34" charset="0"/>
+                <a:ea typeface="Be Vietnam Pro" pitchFamily="34" charset="-122"/>
+                <a:cs typeface="Be Vietnam Pro" pitchFamily="34" charset="-120"/>
+              </a:rPr>
+              <a:t> Cheat</a:t>
+            </a:r>
+            <a:r>
+              <a:rPr lang="en-US" sz="1950" dirty="0" spc="-4" kern="0">
+                <a:solidFill>
+                  <a:srgbClr val="F3EEE3"/>
+                </a:solidFill>
+                <a:latin typeface="Be Vietnam Pro" pitchFamily="34" charset="0"/>
+                <a:ea typeface="Be Vietnam Pro" pitchFamily="34" charset="-122"/>
+                <a:cs typeface="Be Vietnam Pro" pitchFamily="34" charset="-120"/>
+              </a:rPr>
+              <a:t> Sheet</a:t>
+            </a:r>
+            <a:r>
+              <a:rPr lang="en-US" sz="1950" dirty="0" spc="8" kern="0">
+                <a:solidFill>
+                  <a:srgbClr val="F3EEE3"/>
+                </a:solidFill>
+                <a:latin typeface="Be Vietnam Pro" pitchFamily="34" charset="0"/>
+                <a:ea typeface="Be Vietnam Pro" pitchFamily="34" charset="-122"/>
+                <a:cs typeface="Be Vietnam Pro" pitchFamily="34" charset="-120"/>
+              </a:rPr>
+              <a:t> Series)</a:t>
+            </a:r>
+            <a:r>
+              <a:rPr lang="en-US" sz="1950" dirty="0" spc="-2" kern="0">
+                <a:solidFill>
+                  <a:srgbClr val="F3EEE3"/>
+                </a:solidFill>
+                <a:latin typeface="Be Vietnam Pro" pitchFamily="34" charset="0"/>
+                <a:ea typeface="Be Vietnam Pro" pitchFamily="34" charset="-122"/>
+                <a:cs typeface="Be Vietnam Pro" pitchFamily="34" charset="-120"/>
+              </a:rPr>
+              <a:t> ·</a:t>
+            </a:r>
+            <a:r>
+              <a:rPr lang="en-US" sz="1950" dirty="0" spc="-1" kern="0">
+                <a:solidFill>
+                  <a:srgbClr val="F3EEE3"/>
+                </a:solidFill>
+                <a:latin typeface="Be Vietnam Pro" pitchFamily="34" charset="0"/>
+                <a:ea typeface="Be Vietnam Pro" pitchFamily="34" charset="-122"/>
+                <a:cs typeface="Be Vietnam Pro" pitchFamily="34" charset="-120"/>
+              </a:rPr>
+              <a:t> MDN</a:t>
+            </a:r>
+            <a:r>
+              <a:rPr lang="en-US" sz="1950" dirty="0" spc="-2" kern="0">
+                <a:solidFill>
+                  <a:srgbClr val="F3EEE3"/>
+                </a:solidFill>
+                <a:latin typeface="Be Vietnam Pro" pitchFamily="34" charset="0"/>
+                <a:ea typeface="Be Vietnam Pro" pitchFamily="34" charset="-122"/>
+                <a:cs typeface="Be Vietnam Pro" pitchFamily="34" charset="-120"/>
+              </a:rPr>
+              <a:t> · segno ·</a:t>
+            </a:r>
+            <a:r>
+              <a:rPr lang="en-US" sz="1950" dirty="0" spc="6" kern="0">
+                <a:solidFill>
+                  <a:srgbClr val="F3EEE3"/>
+                </a:solidFill>
+                <a:latin typeface="Be Vietnam Pro" pitchFamily="34" charset="0"/>
+                <a:ea typeface="Be Vietnam Pro" pitchFamily="34" charset="-122"/>
+                <a:cs typeface="Be Vietnam Pro" pitchFamily="34" charset="-120"/>
+              </a:rPr>
+              <a:t> PyJWT</a:t>
+            </a:r>
+            <a:endParaRPr lang="en-US" sz="1950" dirty="0"/>
           </a:p>
         </p:txBody>
       </p:sp>
       <p:sp>
         <p:nvSpPr>
-          <p:cNvPr id="39" name="Text 37"/>
-          <p:cNvSpPr/>
-          <p:nvPr/>
-        </p:nvSpPr>
-        <p:spPr>
-          <a:xfrm>
-            <a:off x="12287250" y="6400800"/>
-            <a:ext cx="4857750" cy="723900"/>
-          </a:xfrm>
-          <a:prstGeom prst="rect">
-            <a:avLst/>
-          </a:prstGeom>
-          <a:noFill/>
-          <a:ln/>
-        </p:spPr>
-        <p:txBody>
-          <a:bodyPr wrap="square" lIns="0" tIns="11335" rIns="0" bIns="-11335" rtlCol="0" anchor="t"/>
-          <a:lstStyle/>
-          <a:p>
-            <a:pPr algn="l" indent="0" marL="0">
-              <a:lnSpc>
-                <a:spcPts val="2730"/>
-              </a:lnSpc>
-              <a:buNone/>
-            </a:pPr>
-            <a:r>
-              <a:rPr lang="en-US" sz="2100" dirty="0" spc="-96" kern="0">
-                <a:solidFill>
-                  <a:srgbClr val="D8D3C4"/>
-                </a:solidFill>
-                <a:latin typeface="Be Vietnam Pro" pitchFamily="34" charset="0"/>
-                <a:ea typeface="Be Vietnam Pro" pitchFamily="34" charset="-122"/>
-                <a:cs typeface="Be Vietnam Pro" pitchFamily="34" charset="-120"/>
-              </a:rPr>
-              <a:t>Tổ</a:t>
-            </a:r>
-            <a:r>
-              <a:rPr lang="en-US" sz="2100" dirty="0" spc="6" kern="0">
-                <a:solidFill>
-                  <a:srgbClr val="D8D3C4"/>
-                </a:solidFill>
-                <a:latin typeface="Be Vietnam Pro" pitchFamily="34" charset="0"/>
-                <a:ea typeface="Be Vietnam Pro" pitchFamily="34" charset="-122"/>
-                <a:cs typeface="Be Vietnam Pro" pitchFamily="34" charset="-120"/>
-              </a:rPr>
-              <a:t> chức</a:t>
-            </a:r>
-            <a:r>
-              <a:rPr lang="en-US" sz="2100" dirty="0" spc="-2" kern="0">
-                <a:solidFill>
-                  <a:srgbClr val="D8D3C4"/>
-                </a:solidFill>
-                <a:latin typeface="Be Vietnam Pro" pitchFamily="34" charset="0"/>
-                <a:ea typeface="Be Vietnam Pro" pitchFamily="34" charset="-122"/>
-                <a:cs typeface="Be Vietnam Pro" pitchFamily="34" charset="-120"/>
-              </a:rPr>
-              <a:t> cộng</a:t>
-            </a:r>
-            <a:r>
-              <a:rPr lang="en-US" sz="2100" dirty="0" spc="8" kern="0">
-                <a:solidFill>
-                  <a:srgbClr val="D8D3C4"/>
-                </a:solidFill>
-                <a:latin typeface="Be Vietnam Pro" pitchFamily="34" charset="0"/>
-                <a:ea typeface="Be Vietnam Pro" pitchFamily="34" charset="-122"/>
-                <a:cs typeface="Be Vietnam Pro" pitchFamily="34" charset="-120"/>
-              </a:rPr>
-              <a:t> đồng</a:t>
-            </a:r>
-            <a:r>
-              <a:rPr lang="en-US" sz="2100" dirty="0" spc="-10" kern="0">
-                <a:solidFill>
-                  <a:srgbClr val="D8D3C4"/>
-                </a:solidFill>
-                <a:latin typeface="Be Vietnam Pro" pitchFamily="34" charset="0"/>
-                <a:ea typeface="Be Vietnam Pro" pitchFamily="34" charset="-122"/>
-                <a:cs typeface="Be Vietnam Pro" pitchFamily="34" charset="-120"/>
-              </a:rPr>
-              <a:t> chuyên</a:t>
-            </a:r>
-            <a:r>
-              <a:rPr lang="en-US" sz="2100" dirty="0" spc="-15" kern="0">
-                <a:solidFill>
-                  <a:srgbClr val="D8D3C4"/>
-                </a:solidFill>
-                <a:latin typeface="Be Vietnam Pro" pitchFamily="34" charset="0"/>
-                <a:ea typeface="Be Vietnam Pro" pitchFamily="34" charset="-122"/>
-                <a:cs typeface="Be Vietnam Pro" pitchFamily="34" charset="-120"/>
-              </a:rPr>
-              <a:t> về</a:t>
-            </a:r>
-            <a:r>
-              <a:rPr lang="en-US" sz="2100" dirty="0" spc="-7" kern="0">
-                <a:solidFill>
-                  <a:srgbClr val="D8D3C4"/>
-                </a:solidFill>
-                <a:latin typeface="Be Vietnam Pro" pitchFamily="34" charset="0"/>
-                <a:ea typeface="Be Vietnam Pro" pitchFamily="34" charset="-122"/>
-                <a:cs typeface="Be Vietnam Pro" pitchFamily="34" charset="-120"/>
-              </a:rPr>
-              <a:t> bảo</a:t>
-            </a:r>
-            <a:r>
-              <a:rPr lang="en-US" sz="2100" dirty="0" spc="-13" kern="0">
-                <a:solidFill>
-                  <a:srgbClr val="D8D3C4"/>
-                </a:solidFill>
-                <a:latin typeface="Be Vietnam Pro" pitchFamily="34" charset="0"/>
-                <a:ea typeface="Be Vietnam Pro" pitchFamily="34" charset="-122"/>
-                <a:cs typeface="Be Vietnam Pro" pitchFamily="34" charset="-120"/>
-              </a:rPr>
-              <a:t> mật</a:t>
-            </a:r>
-            <a:r>
-              <a:rPr lang="en-US" sz="2100" dirty="0" spc="22" kern="0">
-                <a:solidFill>
-                  <a:srgbClr val="D8D3C4"/>
-                </a:solidFill>
-                <a:latin typeface="Be Vietnam Pro" pitchFamily="34" charset="0"/>
-                <a:ea typeface="Be Vietnam Pro" pitchFamily="34" charset="-122"/>
-                <a:cs typeface="Be Vietnam Pro" pitchFamily="34" charset="-120"/>
-              </a:rPr>
-              <a:t> ứng</a:t>
-            </a:r>
-            <a:r>
-              <a:rPr lang="en-US" sz="2100" dirty="0" spc="0" kern="0">
-                <a:solidFill>
-                  <a:srgbClr val="D8D3C4"/>
-                </a:solidFill>
-                <a:latin typeface="Be Vietnam Pro" pitchFamily="34" charset="0"/>
-                <a:ea typeface="Be Vietnam Pro" pitchFamily="34" charset="-122"/>
-                <a:cs typeface="Be Vietnam Pro" pitchFamily="34" charset="-120"/>
-              </a:rPr>
-              <a:t> dụng.</a:t>
-            </a:r>
-            <a:endParaRPr lang="en-US" sz="2100" dirty="0"/>
-          </a:p>
-        </p:txBody>
-      </p:sp>
-      <p:sp>
-        <p:nvSpPr>
-          <p:cNvPr id="40" name="Text 38"/>
-          <p:cNvSpPr/>
-          <p:nvPr/>
-        </p:nvSpPr>
-        <p:spPr>
-          <a:xfrm>
-            <a:off x="914400" y="7524750"/>
-            <a:ext cx="7620000" cy="323850"/>
+          <p:cNvPr id="34" name="Text 32"/>
+          <p:cNvSpPr/>
+          <p:nvPr/>
+        </p:nvSpPr>
+        <p:spPr>
+          <a:xfrm>
+            <a:off x="914400" y="8629650"/>
+            <a:ext cx="16459200" cy="304800"/>
           </a:xfrm>
           <a:prstGeom prst="rect">
             <a:avLst/>
@@ -5901,41 +6024,129 @@
               <a:buNone/>
             </a:pPr>
             <a:r>
-              <a:rPr lang="en-US" sz="1800" b="1" spc="225" kern="0" dirty="0">
-                <a:solidFill>
-                  <a:srgbClr val="FF6A4D"/>
-                </a:solidFill>
-                <a:latin typeface="Be Vietnam Pro" pitchFamily="34" charset="0"/>
-                <a:ea typeface="Be Vietnam Pro" pitchFamily="34" charset="-122"/>
-                <a:cs typeface="Be Vietnam Pro" pitchFamily="34" charset="-120"/>
-              </a:rPr>
-              <a:t>NGUỒN ĐỐI</a:t>
-            </a:r>
-            <a:r>
-              <a:rPr lang="en-US" sz="1800" b="1" spc="227" kern="0" dirty="0">
-                <a:solidFill>
-                  <a:srgbClr val="FF6A4D"/>
-                </a:solidFill>
-                <a:latin typeface="Be Vietnam Pro" pitchFamily="34" charset="0"/>
-                <a:ea typeface="Be Vietnam Pro" pitchFamily="34" charset="-122"/>
-                <a:cs typeface="Be Vietnam Pro" pitchFamily="34" charset="-120"/>
-              </a:rPr>
-              <a:t> CHIẾU</a:t>
-            </a:r>
-            <a:endParaRPr lang="en-US" sz="1800" dirty="0"/>
+              <a:rPr lang="en-US" sz="1650" dirty="0" spc="1" kern="0">
+                <a:solidFill>
+                  <a:srgbClr val="9A98A0"/>
+                </a:solidFill>
+                <a:latin typeface="Be Vietnam Pro" pitchFamily="34" charset="0"/>
+                <a:ea typeface="Be Vietnam Pro" pitchFamily="34" charset="-122"/>
+                <a:cs typeface="Be Vietnam Pro" pitchFamily="34" charset="-120"/>
+              </a:rPr>
+              <a:t>Đã</a:t>
+            </a:r>
+            <a:r>
+              <a:rPr lang="en-US" sz="1650" dirty="0" spc="10" kern="0">
+                <a:solidFill>
+                  <a:srgbClr val="9A98A0"/>
+                </a:solidFill>
+                <a:latin typeface="Be Vietnam Pro" pitchFamily="34" charset="0"/>
+                <a:ea typeface="Be Vietnam Pro" pitchFamily="34" charset="-122"/>
+                <a:cs typeface="Be Vietnam Pro" pitchFamily="34" charset="-120"/>
+              </a:rPr>
+              <a:t> đối</a:t>
+            </a:r>
+            <a:r>
+              <a:rPr lang="en-US" sz="1650" dirty="0" spc="1" kern="0">
+                <a:solidFill>
+                  <a:srgbClr val="9A98A0"/>
+                </a:solidFill>
+                <a:latin typeface="Be Vietnam Pro" pitchFamily="34" charset="0"/>
+                <a:ea typeface="Be Vietnam Pro" pitchFamily="34" charset="-122"/>
+                <a:cs typeface="Be Vietnam Pro" pitchFamily="34" charset="-120"/>
+              </a:rPr>
+              <a:t> chiếu</a:t>
+            </a:r>
+            <a:r>
+              <a:rPr lang="en-US" sz="1650" dirty="0" spc="-12" kern="0">
+                <a:solidFill>
+                  <a:srgbClr val="9A98A0"/>
+                </a:solidFill>
+                <a:latin typeface="Be Vietnam Pro" pitchFamily="34" charset="0"/>
+                <a:ea typeface="Be Vietnam Pro" pitchFamily="34" charset="-122"/>
+                <a:cs typeface="Be Vietnam Pro" pitchFamily="34" charset="-120"/>
+              </a:rPr>
+              <a:t> ngày</a:t>
+            </a:r>
+            <a:r>
+              <a:rPr lang="en-US" sz="1650" dirty="0" spc="0" kern="0">
+                <a:solidFill>
+                  <a:srgbClr val="9A98A0"/>
+                </a:solidFill>
+                <a:latin typeface="Be Vietnam Pro" pitchFamily="34" charset="0"/>
+                <a:ea typeface="Be Vietnam Pro" pitchFamily="34" charset="-122"/>
+                <a:cs typeface="Be Vietnam Pro" pitchFamily="34" charset="-120"/>
+              </a:rPr>
+              <a:t> 2026-10-18. Hình</a:t>
+            </a:r>
+            <a:r>
+              <a:rPr lang="en-US" sz="1650" dirty="0" spc="-1" kern="0">
+                <a:solidFill>
+                  <a:srgbClr val="9A98A0"/>
+                </a:solidFill>
+                <a:latin typeface="Be Vietnam Pro" pitchFamily="34" charset="0"/>
+                <a:ea typeface="Be Vietnam Pro" pitchFamily="34" charset="-122"/>
+                <a:cs typeface="Be Vietnam Pro" pitchFamily="34" charset="-120"/>
+              </a:rPr>
+              <a:t> minh họa</a:t>
+            </a:r>
+            <a:r>
+              <a:rPr lang="en-US" sz="1650" dirty="0" spc="1" kern="0">
+                <a:solidFill>
+                  <a:srgbClr val="9A98A0"/>
+                </a:solidFill>
+                <a:latin typeface="Be Vietnam Pro" pitchFamily="34" charset="0"/>
+                <a:ea typeface="Be Vietnam Pro" pitchFamily="34" charset="-122"/>
+                <a:cs typeface="Be Vietnam Pro" pitchFamily="34" charset="-120"/>
+              </a:rPr>
+              <a:t> là</a:t>
+            </a:r>
+            <a:r>
+              <a:rPr lang="en-US" sz="1650" dirty="0" spc="0" kern="0">
+                <a:solidFill>
+                  <a:srgbClr val="9A98A0"/>
+                </a:solidFill>
+                <a:latin typeface="Be Vietnam Pro" pitchFamily="34" charset="0"/>
+                <a:ea typeface="Be Vietnam Pro" pitchFamily="34" charset="-122"/>
+                <a:cs typeface="Be Vietnam Pro" pitchFamily="34" charset="-120"/>
+              </a:rPr>
+              <a:t> thiết</a:t>
+            </a:r>
+            <a:r>
+              <a:rPr lang="en-US" sz="1650" dirty="0" spc="-20" kern="0">
+                <a:solidFill>
+                  <a:srgbClr val="9A98A0"/>
+                </a:solidFill>
+                <a:latin typeface="Be Vietnam Pro" pitchFamily="34" charset="0"/>
+                <a:ea typeface="Be Vietnam Pro" pitchFamily="34" charset="-122"/>
+                <a:cs typeface="Be Vietnam Pro" pitchFamily="34" charset="-120"/>
+              </a:rPr>
+              <a:t> kế</a:t>
+            </a:r>
+            <a:r>
+              <a:rPr lang="en-US" sz="1650" dirty="0" spc="0" kern="0">
+                <a:solidFill>
+                  <a:srgbClr val="9A98A0"/>
+                </a:solidFill>
+                <a:latin typeface="Be Vietnam Pro" pitchFamily="34" charset="0"/>
+                <a:ea typeface="Be Vietnam Pro" pitchFamily="34" charset="-122"/>
+                <a:cs typeface="Be Vietnam Pro" pitchFamily="34" charset="-120"/>
+              </a:rPr>
+              <a:t> mới.</a:t>
+            </a:r>
+            <a:endParaRPr lang="en-US" sz="1650" dirty="0"/>
           </a:p>
         </p:txBody>
       </p:sp>
       <p:sp>
         <p:nvSpPr>
-          <p:cNvPr id="41" name="Text 39"/>
-          <p:cNvSpPr/>
-          <p:nvPr/>
-        </p:nvSpPr>
-        <p:spPr>
-          <a:xfrm>
-            <a:off x="914400" y="7924800"/>
-            <a:ext cx="16459200" cy="419100"/>
+          <p:cNvPr id="35" name="Text 33"/>
+          <p:cNvSpPr/>
+          <p:nvPr/>
+        </p:nvSpPr>
+        <p:spPr>
+          <a:xfrm>
+            <a:off x="914400" y="9715500"/>
+            <a:ext cx="7620000" cy="285750"/>
           </a:xfrm>
           <a:prstGeom prst="rect">
             <a:avLst/>
@@ -5951,337 +6162,6 @@
               <a:buNone/>
             </a:pPr>
             <a:r>
-              <a:rPr lang="en-US" sz="2250" dirty="0" spc="-5" kern="0">
-                <a:solidFill>
-                  <a:srgbClr val="F3EEE3"/>
-                </a:solidFill>
-                <a:latin typeface="Be Vietnam Pro" pitchFamily="34" charset="0"/>
-                <a:ea typeface="Be Vietnam Pro" pitchFamily="34" charset="-122"/>
-                <a:cs typeface="Be Vietnam Pro" pitchFamily="34" charset="-120"/>
-              </a:rPr>
-              <a:t>ByteByteGo</a:t>
-            </a:r>
-            <a:r>
-              <a:rPr lang="en-US" sz="2250" dirty="0" spc="3" kern="0">
-                <a:solidFill>
-                  <a:srgbClr val="F3EEE3"/>
-                </a:solidFill>
-                <a:latin typeface="Be Vietnam Pro" pitchFamily="34" charset="0"/>
-                <a:ea typeface="Be Vietnam Pro" pitchFamily="34" charset="-122"/>
-                <a:cs typeface="Be Vietnam Pro" pitchFamily="34" charset="-120"/>
-              </a:rPr>
-              <a:t> ·</a:t>
-            </a:r>
-            <a:r>
-              <a:rPr lang="en-US" sz="2250" dirty="0" spc="-47" kern="0">
-                <a:solidFill>
-                  <a:srgbClr val="F3EEE3"/>
-                </a:solidFill>
-                <a:latin typeface="Be Vietnam Pro" pitchFamily="34" charset="0"/>
-                <a:ea typeface="Be Vietnam Pro" pitchFamily="34" charset="-122"/>
-                <a:cs typeface="Be Vietnam Pro" pitchFamily="34" charset="-120"/>
-              </a:rPr>
-              <a:t> OWASP</a:t>
-            </a:r>
-            <a:r>
-              <a:rPr lang="en-US" sz="2250" dirty="0" spc="-1" kern="0">
-                <a:solidFill>
-                  <a:srgbClr val="F3EEE3"/>
-                </a:solidFill>
-                <a:latin typeface="Be Vietnam Pro" pitchFamily="34" charset="0"/>
-                <a:ea typeface="Be Vietnam Pro" pitchFamily="34" charset="-122"/>
-                <a:cs typeface="Be Vietnam Pro" pitchFamily="34" charset="-120"/>
-              </a:rPr>
-              <a:t> (QRLJacking,</a:t>
-            </a:r>
-            <a:r>
-              <a:rPr lang="en-US" sz="2250" dirty="0" spc="-10" kern="0">
-                <a:solidFill>
-                  <a:srgbClr val="F3EEE3"/>
-                </a:solidFill>
-                <a:latin typeface="Be Vietnam Pro" pitchFamily="34" charset="0"/>
-                <a:ea typeface="Be Vietnam Pro" pitchFamily="34" charset="-122"/>
-                <a:cs typeface="Be Vietnam Pro" pitchFamily="34" charset="-120"/>
-              </a:rPr>
-              <a:t> Cheat</a:t>
-            </a:r>
-            <a:r>
-              <a:rPr lang="en-US" sz="2250" dirty="0" spc="-5" kern="0">
-                <a:solidFill>
-                  <a:srgbClr val="F3EEE3"/>
-                </a:solidFill>
-                <a:latin typeface="Be Vietnam Pro" pitchFamily="34" charset="0"/>
-                <a:ea typeface="Be Vietnam Pro" pitchFamily="34" charset="-122"/>
-                <a:cs typeface="Be Vietnam Pro" pitchFamily="34" charset="-120"/>
-              </a:rPr>
-              <a:t> Sheet</a:t>
-            </a:r>
-            <a:r>
-              <a:rPr lang="en-US" sz="2250" dirty="0" spc="5" kern="0">
-                <a:solidFill>
-                  <a:srgbClr val="F3EEE3"/>
-                </a:solidFill>
-                <a:latin typeface="Be Vietnam Pro" pitchFamily="34" charset="0"/>
-                <a:ea typeface="Be Vietnam Pro" pitchFamily="34" charset="-122"/>
-                <a:cs typeface="Be Vietnam Pro" pitchFamily="34" charset="-120"/>
-              </a:rPr>
-              <a:t> Series)</a:t>
-            </a:r>
-            <a:r>
-              <a:rPr lang="en-US" sz="2250" dirty="0" spc="2" kern="0">
-                <a:solidFill>
-                  <a:srgbClr val="F3EEE3"/>
-                </a:solidFill>
-                <a:latin typeface="Be Vietnam Pro" pitchFamily="34" charset="0"/>
-                <a:ea typeface="Be Vietnam Pro" pitchFamily="34" charset="-122"/>
-                <a:cs typeface="Be Vietnam Pro" pitchFamily="34" charset="-120"/>
-              </a:rPr>
-              <a:t> ·</a:t>
-            </a:r>
-            <a:r>
-              <a:rPr lang="en-US" sz="2250" dirty="0" spc="-1" kern="0">
-                <a:solidFill>
-                  <a:srgbClr val="F3EEE3"/>
-                </a:solidFill>
-                <a:latin typeface="Be Vietnam Pro" pitchFamily="34" charset="0"/>
-                <a:ea typeface="Be Vietnam Pro" pitchFamily="34" charset="-122"/>
-                <a:cs typeface="Be Vietnam Pro" pitchFamily="34" charset="-120"/>
-              </a:rPr>
-              <a:t> MDN</a:t>
-            </a:r>
-            <a:r>
-              <a:rPr lang="en-US" sz="2250" dirty="0" spc="3" kern="0">
-                <a:solidFill>
-                  <a:srgbClr val="F3EEE3"/>
-                </a:solidFill>
-                <a:latin typeface="Be Vietnam Pro" pitchFamily="34" charset="0"/>
-                <a:ea typeface="Be Vietnam Pro" pitchFamily="34" charset="-122"/>
-                <a:cs typeface="Be Vietnam Pro" pitchFamily="34" charset="-120"/>
-              </a:rPr>
-              <a:t> ·</a:t>
-            </a:r>
-            <a:r>
-              <a:rPr lang="en-US" sz="2250" dirty="0" spc="-6" kern="0">
-                <a:solidFill>
-                  <a:srgbClr val="F3EEE3"/>
-                </a:solidFill>
-                <a:latin typeface="Be Vietnam Pro" pitchFamily="34" charset="0"/>
-                <a:ea typeface="Be Vietnam Pro" pitchFamily="34" charset="-122"/>
-                <a:cs typeface="Be Vietnam Pro" pitchFamily="34" charset="-120"/>
-              </a:rPr>
-              <a:t> segno</a:t>
-            </a:r>
-            <a:r>
-              <a:rPr lang="en-US" sz="2250" dirty="0" spc="3" kern="0">
-                <a:solidFill>
-                  <a:srgbClr val="F3EEE3"/>
-                </a:solidFill>
-                <a:latin typeface="Be Vietnam Pro" pitchFamily="34" charset="0"/>
-                <a:ea typeface="Be Vietnam Pro" pitchFamily="34" charset="-122"/>
-                <a:cs typeface="Be Vietnam Pro" pitchFamily="34" charset="-120"/>
-              </a:rPr>
-              <a:t> ·</a:t>
-            </a:r>
-            <a:r>
-              <a:rPr lang="en-US" sz="2250" dirty="0" spc="7" kern="0">
-                <a:solidFill>
-                  <a:srgbClr val="F3EEE3"/>
-                </a:solidFill>
-                <a:latin typeface="Be Vietnam Pro" pitchFamily="34" charset="0"/>
-                <a:ea typeface="Be Vietnam Pro" pitchFamily="34" charset="-122"/>
-                <a:cs typeface="Be Vietnam Pro" pitchFamily="34" charset="-120"/>
-              </a:rPr>
-              <a:t> PyJWT</a:t>
-            </a:r>
-            <a:endParaRPr lang="en-US" sz="2250" dirty="0"/>
-          </a:p>
-        </p:txBody>
-      </p:sp>
-      <p:sp>
-        <p:nvSpPr>
-          <p:cNvPr id="42" name="Text 40"/>
-          <p:cNvSpPr/>
-          <p:nvPr/>
-        </p:nvSpPr>
-        <p:spPr>
-          <a:xfrm>
-            <a:off x="914400" y="8477250"/>
-            <a:ext cx="16459200" cy="323850"/>
-          </a:xfrm>
-          <a:prstGeom prst="rect">
-            <a:avLst/>
-          </a:prstGeom>
-          <a:noFill/>
-          <a:ln/>
-        </p:spPr>
-        <p:txBody>
-          <a:bodyPr wrap="square" lIns="0" tIns="0" rIns="0" bIns="0" rtlCol="0" anchor="t"/>
-          <a:lstStyle/>
-          <a:p>
-            <a:pPr algn="l" indent="0" marL="0">
-              <a:buNone/>
-            </a:pPr>
-            <a:r>
-              <a:rPr lang="en-US" sz="1800" dirty="0" spc="3" kern="0">
-                <a:solidFill>
-                  <a:srgbClr val="9A98A0"/>
-                </a:solidFill>
-                <a:latin typeface="Be Vietnam Pro" pitchFamily="34" charset="0"/>
-                <a:ea typeface="Be Vietnam Pro" pitchFamily="34" charset="-122"/>
-                <a:cs typeface="Be Vietnam Pro" pitchFamily="34" charset="-120"/>
-              </a:rPr>
-              <a:t>Đã</a:t>
-            </a:r>
-            <a:r>
-              <a:rPr lang="en-US" sz="1800" dirty="0" spc="10" kern="0">
-                <a:solidFill>
-                  <a:srgbClr val="9A98A0"/>
-                </a:solidFill>
-                <a:latin typeface="Be Vietnam Pro" pitchFamily="34" charset="0"/>
-                <a:ea typeface="Be Vietnam Pro" pitchFamily="34" charset="-122"/>
-                <a:cs typeface="Be Vietnam Pro" pitchFamily="34" charset="-120"/>
-              </a:rPr>
-              <a:t> đối</a:t>
-            </a:r>
-            <a:r>
-              <a:rPr lang="en-US" sz="1800" dirty="0" spc="-1" kern="0">
-                <a:solidFill>
-                  <a:srgbClr val="9A98A0"/>
-                </a:solidFill>
-                <a:latin typeface="Be Vietnam Pro" pitchFamily="34" charset="0"/>
-                <a:ea typeface="Be Vietnam Pro" pitchFamily="34" charset="-122"/>
-                <a:cs typeface="Be Vietnam Pro" pitchFamily="34" charset="-120"/>
-              </a:rPr>
-              <a:t> chiếu</a:t>
-            </a:r>
-            <a:r>
-              <a:rPr lang="en-US" sz="1800" dirty="0" spc="-14" kern="0">
-                <a:solidFill>
-                  <a:srgbClr val="9A98A0"/>
-                </a:solidFill>
-                <a:latin typeface="Be Vietnam Pro" pitchFamily="34" charset="0"/>
-                <a:ea typeface="Be Vietnam Pro" pitchFamily="34" charset="-122"/>
-                <a:cs typeface="Be Vietnam Pro" pitchFamily="34" charset="-120"/>
-              </a:rPr>
-              <a:t> ngày</a:t>
-            </a:r>
-            <a:r>
-              <a:rPr lang="en-US" sz="1800" dirty="0" spc="1" kern="0">
-                <a:solidFill>
-                  <a:srgbClr val="9A98A0"/>
-                </a:solidFill>
-                <a:latin typeface="Be Vietnam Pro" pitchFamily="34" charset="0"/>
-                <a:ea typeface="Be Vietnam Pro" pitchFamily="34" charset="-122"/>
-                <a:cs typeface="Be Vietnam Pro" pitchFamily="34" charset="-120"/>
-              </a:rPr>
-              <a:t> 2026-10-18.</a:t>
-            </a:r>
-            <a:r>
-              <a:rPr lang="en-US" sz="1800" dirty="0" spc="-2" kern="0">
-                <a:solidFill>
-                  <a:srgbClr val="9A98A0"/>
-                </a:solidFill>
-                <a:latin typeface="Be Vietnam Pro" pitchFamily="34" charset="0"/>
-                <a:ea typeface="Be Vietnam Pro" pitchFamily="34" charset="-122"/>
-                <a:cs typeface="Be Vietnam Pro" pitchFamily="34" charset="-120"/>
-              </a:rPr>
-              <a:t> Hình</a:t>
-            </a:r>
-            <a:r>
-              <a:rPr lang="en-US" sz="1800" dirty="0" spc="-3" kern="0">
-                <a:solidFill>
-                  <a:srgbClr val="9A98A0"/>
-                </a:solidFill>
-                <a:latin typeface="Be Vietnam Pro" pitchFamily="34" charset="0"/>
-                <a:ea typeface="Be Vietnam Pro" pitchFamily="34" charset="-122"/>
-                <a:cs typeface="Be Vietnam Pro" pitchFamily="34" charset="-120"/>
-              </a:rPr>
-              <a:t> minh</a:t>
-            </a:r>
-            <a:r>
-              <a:rPr lang="en-US" sz="1800" dirty="0" spc="0" kern="0">
-                <a:solidFill>
-                  <a:srgbClr val="9A98A0"/>
-                </a:solidFill>
-                <a:latin typeface="Be Vietnam Pro" pitchFamily="34" charset="0"/>
-                <a:ea typeface="Be Vietnam Pro" pitchFamily="34" charset="-122"/>
-                <a:cs typeface="Be Vietnam Pro" pitchFamily="34" charset="-120"/>
-              </a:rPr>
-              <a:t> họa</a:t>
-            </a:r>
-            <a:r>
-              <a:rPr lang="en-US" sz="1800" dirty="0" spc="-1" kern="0">
-                <a:solidFill>
-                  <a:srgbClr val="9A98A0"/>
-                </a:solidFill>
-                <a:latin typeface="Be Vietnam Pro" pitchFamily="34" charset="0"/>
-                <a:ea typeface="Be Vietnam Pro" pitchFamily="34" charset="-122"/>
-                <a:cs typeface="Be Vietnam Pro" pitchFamily="34" charset="-120"/>
-              </a:rPr>
-              <a:t> là</a:t>
-            </a:r>
-            <a:r>
-              <a:rPr lang="en-US" sz="1800" dirty="0" spc="-5" kern="0">
-                <a:solidFill>
-                  <a:srgbClr val="9A98A0"/>
-                </a:solidFill>
-                <a:latin typeface="Be Vietnam Pro" pitchFamily="34" charset="0"/>
-                <a:ea typeface="Be Vietnam Pro" pitchFamily="34" charset="-122"/>
-                <a:cs typeface="Be Vietnam Pro" pitchFamily="34" charset="-120"/>
-              </a:rPr>
-              <a:t> thiết</a:t>
-            </a:r>
-            <a:r>
-              <a:rPr lang="en-US" sz="1800" dirty="0" spc="-28" kern="0">
-                <a:solidFill>
-                  <a:srgbClr val="9A98A0"/>
-                </a:solidFill>
-                <a:latin typeface="Be Vietnam Pro" pitchFamily="34" charset="0"/>
-                <a:ea typeface="Be Vietnam Pro" pitchFamily="34" charset="-122"/>
-                <a:cs typeface="Be Vietnam Pro" pitchFamily="34" charset="-120"/>
-              </a:rPr>
-              <a:t> kế</a:t>
-            </a:r>
-            <a:r>
-              <a:rPr lang="en-US" sz="1800" dirty="0" spc="-1" kern="0">
-                <a:solidFill>
-                  <a:srgbClr val="9A98A0"/>
-                </a:solidFill>
-                <a:latin typeface="Be Vietnam Pro" pitchFamily="34" charset="0"/>
-                <a:ea typeface="Be Vietnam Pro" pitchFamily="34" charset="-122"/>
-                <a:cs typeface="Be Vietnam Pro" pitchFamily="34" charset="-120"/>
-              </a:rPr>
-              <a:t> mới.</a:t>
-            </a:r>
-            <a:endParaRPr lang="en-US" sz="1800" dirty="0"/>
-          </a:p>
-        </p:txBody>
-      </p:sp>
-      <p:sp>
-        <p:nvSpPr>
-          <p:cNvPr id="43" name="Text 41"/>
-          <p:cNvSpPr/>
-          <p:nvPr/>
-        </p:nvSpPr>
-        <p:spPr>
-          <a:xfrm>
-            <a:off x="914400" y="9715500"/>
-            <a:ext cx="7620000" cy="285750"/>
-          </a:xfrm>
-          <a:prstGeom prst="rect">
-            <a:avLst/>
-          </a:prstGeom>
-          <a:noFill/>
-          <a:ln/>
-        </p:spPr>
-        <p:txBody>
-          <a:bodyPr wrap="square" lIns="0" tIns="0" rIns="0" bIns="0" rtlCol="0" anchor="t"/>
-          <a:lstStyle/>
-          <a:p>
-            <a:pPr algn="l" indent="0" marL="0">
-              <a:buNone/>
-            </a:pPr>
-            <a:r>
               <a:rPr lang="en-US" sz="1650" dirty="0" spc="-12" kern="0">
                 <a:solidFill>
                   <a:srgbClr val="9A98A0"/>
@@ -6375,7 +6255,7 @@
       </p:sp>
       <p:sp>
         <p:nvSpPr>
-          <p:cNvPr id="44" name="Connector line-1792369924408-34124076"/>
+          <p:cNvPr id="36" name="Connector line-1792390670827-406777542"/>
           <p:cNvSpPr/>
           <p:nvPr/>
         </p:nvSpPr>
@@ -6402,7 +6282,7 @@
       </p:sp>
       <p:sp>
         <p:nvSpPr>
-          <p:cNvPr id="45" name="Shape 43"/>
+          <p:cNvPr id="37" name="Shape 35"/>
           <p:cNvSpPr/>
           <p:nvPr/>
         </p:nvSpPr>
@@ -6422,7 +6302,7 @@
       </p:sp>
       <p:sp>
         <p:nvSpPr>
-          <p:cNvPr id="46" name="Shape 44"/>
+          <p:cNvPr id="38" name="Shape 36"/>
           <p:cNvSpPr/>
           <p:nvPr/>
         </p:nvSpPr>
@@ -6442,7 +6322,7 @@
       </p:sp>
       <p:sp>
         <p:nvSpPr>
-          <p:cNvPr id="47" name="Shape 45"/>
+          <p:cNvPr id="39" name="Shape 37"/>
           <p:cNvSpPr/>
           <p:nvPr/>
         </p:nvSpPr>
@@ -6462,7 +6342,7 @@
       </p:sp>
       <p:sp>
         <p:nvSpPr>
-          <p:cNvPr id="48" name="Shape 46"/>
+          <p:cNvPr id="40" name="Shape 38"/>
           <p:cNvSpPr/>
           <p:nvPr/>
         </p:nvSpPr>
@@ -6482,7 +6362,7 @@
       </p:sp>
       <p:sp>
         <p:nvSpPr>
-          <p:cNvPr id="49" name="Shape 47"/>
+          <p:cNvPr id="41" name="Shape 39"/>
           <p:cNvSpPr/>
           <p:nvPr/>
         </p:nvSpPr>
@@ -6502,7 +6382,7 @@
       </p:sp>
       <p:sp>
         <p:nvSpPr>
-          <p:cNvPr id="50" name="Shape 48"/>
+          <p:cNvPr id="42" name="Shape 40"/>
           <p:cNvSpPr/>
           <p:nvPr/>
         </p:nvSpPr>
@@ -6522,7 +6402,7 @@
       </p:sp>
       <p:sp>
         <p:nvSpPr>
-          <p:cNvPr id="51" name="Shape 49"/>
+          <p:cNvPr id="43" name="Shape 41"/>
           <p:cNvSpPr/>
           <p:nvPr/>
         </p:nvSpPr>
@@ -6542,7 +6422,7 @@
       </p:sp>
       <p:sp>
         <p:nvSpPr>
-          <p:cNvPr id="52" name="Shape 50"/>
+          <p:cNvPr id="44" name="Shape 42"/>
           <p:cNvSpPr/>
           <p:nvPr/>
         </p:nvSpPr>
@@ -6562,7 +6442,7 @@
       </p:sp>
       <p:sp>
         <p:nvSpPr>
-          <p:cNvPr id="53" name="Shape 51"/>
+          <p:cNvPr id="45" name="Shape 43"/>
           <p:cNvSpPr/>
           <p:nvPr/>
         </p:nvSpPr>
@@ -6582,7 +6462,7 @@
       </p:sp>
       <p:sp>
         <p:nvSpPr>
-          <p:cNvPr id="54" name="Shape 52"/>
+          <p:cNvPr id="46" name="Shape 44"/>
           <p:cNvSpPr/>
           <p:nvPr/>
         </p:nvSpPr>
@@ -6602,7 +6482,7 @@
       </p:sp>
       <p:sp>
         <p:nvSpPr>
-          <p:cNvPr id="55" name="Shape 53"/>
+          <p:cNvPr id="47" name="Shape 45"/>
           <p:cNvSpPr/>
           <p:nvPr/>
         </p:nvSpPr>
@@ -6626,7 +6506,7 @@
       </p:sp>
       <p:pic>
         <p:nvPicPr>
-          <p:cNvPr id="56" name="Moda image moda-export-watermark-48ba96b2-bd05-4bba-b783-1f706a4248ac" descr="">    </p:cNvPr>
+          <p:cNvPr id="48" name="Moda image moda-export-watermark-48ba96b2-bd05-4bba-b783-1f706a4248ac" descr="">    </p:cNvPr>
           <p:cNvPicPr>
             <a:picLocks noChangeAspect="1"/>
           </p:cNvPicPr>

</xml_diff>